<commit_message>
Report and deck: corrected promiscuity framing, boundary-control section
The promiscuity comparison is now generated from the measured ranges rather
than asserting a direction, so it tracks the epitope_breadth fix: the universal
epitopes reach 2-6 of 25 DR molecules at EL %Rank < 1 and the test article's
dominant core reaches 6/25 - at the top of that range, not above it.

Adds the boundary-control section to both outputs: MBP85-99 is the broadest
binder in the batch (10/25 strong, unfiltered pIRS 1.19) and the tolerance
filter zeroes it, which is the filter's operating assumption failing on a real
self-derived epitope. CLIP behaves the other way and is not read as risk.

Also softens an unverified mechanism claim in the M11 docstring: the endpoint's
cost tracks request count, but whether that is per-record processing or queue
latency was not isolated.

Co-Authored-By: Claude Opus 5 <noreply@anthropic.com>
Claude-Session: https://claude.ai/code/session_017N9DXiVxu1YxkNxkzE7T75
</commit_message>
<xml_diff>
--- a/hla_ligand_immunogenicity/report.pptx
+++ b/hla_ligand_immunogenicity/report.pptx
@@ -17,9 +17,10 @@
     <p:sldId id="265" r:id="rId11"/>
     <p:sldId id="266" r:id="rId12"/>
     <p:sldId id="267" r:id="rId13"/>
+    <p:sldId id="268" r:id="rId14"/>
   </p:sldIdLst>
   <p:notesMasterIdLst>
-    <p:notesMasterId r:id="rId14"/>
+    <p:notesMasterId r:id="rId15"/>
   </p:notesMasterIdLst>
   <p:sldSz cx="12192000" cy="6858000"/>
   <p:notesSz cx="6858000" cy="12192000"/>
@@ -801,6 +802,94 @@
             <a:fld id="{F7021451-1387-4CA6-816F-3879F97B5CBC}" type="slidenum">
               <a:rPr lang="en-US"/>
               <a:t>12</a:t>
+            </a:fld>
+            <a:endParaRPr lang="en-US"/>
+          </a:p>
+        </p:txBody>
+      </p:sp>
+    </p:spTree>
+    <p:extLst>
+      <p:ext uri="{BB962C8B-B14F-4D97-AF65-F5344CB8AC3E}">
+        <p14:creationId xmlns:p14="http://schemas.microsoft.com/office/powerpoint/2010/main" val="1024086991"/>
+      </p:ext>
+    </p:extLst>
+  </p:cSld>
+  <p:clrMapOvr>
+    <a:masterClrMapping/>
+  </p:clrMapOvr>
+</p:notes>
+</file>
+
+<file path=ppt/notesSlides/notesSlide13.xml><?xml version="1.0" encoding="utf-8"?>
+<p:notes xmlns:a="http://schemas.openxmlformats.org/drawingml/2006/main" xmlns:r="http://schemas.openxmlformats.org/officeDocument/2006/relationships" xmlns:p="http://schemas.openxmlformats.org/presentationml/2006/main">
+  <p:cSld>
+    <p:spTree>
+      <p:nvGrpSpPr>
+        <p:cNvPr id="1" name=""/>
+        <p:cNvGrpSpPr/>
+        <p:nvPr/>
+      </p:nvGrpSpPr>
+      <p:grpSpPr>
+        <a:xfrm>
+          <a:off x="0" y="0"/>
+          <a:ext cx="0" cy="0"/>
+          <a:chOff x="0" y="0"/>
+          <a:chExt cx="0" cy="0"/>
+        </a:xfrm>
+      </p:grpSpPr>
+      <p:sp>
+        <p:nvSpPr>
+          <p:cNvPr id="2" name="Slide Image Placeholder 1"/>
+          <p:cNvSpPr>
+            <a:spLocks noGrp="1" noRot="1" noChangeAspect="1"/>
+          </p:cNvSpPr>
+          <p:nvPr>
+            <p:ph type="sldImg"/>
+          </p:nvPr>
+        </p:nvSpPr>
+        <p:spPr/>
+      </p:sp>
+      <p:sp>
+        <p:nvSpPr>
+          <p:cNvPr id="3" name="Notes Placeholder 2"/>
+          <p:cNvSpPr>
+            <a:spLocks noGrp="1"/>
+          </p:cNvSpPr>
+          <p:nvPr>
+            <p:ph type="body" idx="1"/>
+          </p:nvPr>
+        </p:nvSpPr>
+        <p:spPr/>
+        <p:txBody>
+          <a:bodyPr/>
+          <a:lstStyle/>
+          <a:p>
+            <a:r>
+              <a:rPr lang="en-US" dirty="0"/>
+              <a:t/>
+            </a:r>
+            <a:endParaRPr lang="en-US" dirty="0"/>
+          </a:p>
+        </p:txBody>
+      </p:sp>
+      <p:sp>
+        <p:nvSpPr>
+          <p:cNvPr id="4" name="Slide Number Placeholder 3"/>
+          <p:cNvSpPr>
+            <a:spLocks noGrp="1"/>
+          </p:cNvSpPr>
+          <p:nvPr>
+            <p:ph type="sldNum" sz="quarter" idx="10"/>
+          </p:nvPr>
+        </p:nvSpPr>
+        <p:spPr/>
+        <p:txBody>
+          <a:bodyPr/>
+          <a:lstStyle/>
+          <a:p>
+            <a:fld id="{F7021451-1387-4CA6-816F-3879F97B5CBC}" type="slidenum">
+              <a:rPr lang="en-US"/>
+              <a:t>13</a:t>
             </a:fld>
             <a:endParaRPr lang="en-US"/>
           </a:p>
@@ -1949,7 +2038,7 @@
                 <a:ea typeface="Calibri" pitchFamily="34" charset="-122"/>
                 <a:cs typeface="Calibri" pitchFamily="34" charset="-120"/>
               </a:rPr>
-              <a:t>25-molecule HLA-DR panel · 97.3% weighted US/EU coverage · benchmarked against 9 comparators and controls</a:t>
+              <a:t>25-molecule HLA-DR panel · 97.3% weighted US/EU coverage · benchmarked against 13 comparators and controls</a:t>
             </a:r>
             <a:endParaRPr lang="en-US" sz="1500" dirty="0"/>
           </a:p>
@@ -2098,6 +2187,1060 @@
                 <a:ea typeface="Calibri" pitchFamily="34" charset="-122"/>
                 <a:cs typeface="Calibri" pitchFamily="34" charset="-120"/>
               </a:rPr>
+              <a:t>MODULE 7 · ADA LAYER</a:t>
+            </a:r>
+            <a:endParaRPr lang="en-US" sz="1050" dirty="0"/>
+          </a:p>
+        </p:txBody>
+      </p:sp>
+      <p:sp>
+        <p:nvSpPr>
+          <p:cNvPr id="3" name="Text 1"/>
+          <p:cNvSpPr/>
+          <p:nvPr/>
+        </p:nvSpPr>
+        <p:spPr>
+          <a:xfrm>
+            <a:off x="566928" y="548640"/>
+            <a:ext cx="11027664" cy="548640"/>
+          </a:xfrm>
+          <a:prstGeom prst="rect">
+            <a:avLst/>
+          </a:prstGeom>
+          <a:noFill/>
+          <a:ln/>
+        </p:spPr>
+        <p:txBody>
+          <a:bodyPr wrap="square" lIns="0" tIns="0" rIns="0" bIns="0" rtlCol="0" anchor="ctr"/>
+          <a:lstStyle/>
+          <a:p>
+            <a:pPr indent="0" marL="0">
+              <a:buNone/>
+            </a:pPr>
+            <a:r>
+              <a:rPr lang="en-US" sz="2700" b="1" dirty="0">
+                <a:solidFill>
+                  <a:srgbClr val="12212E"/>
+                </a:solidFill>
+                <a:latin typeface="Cambria" pitchFamily="34" charset="0"/>
+                <a:ea typeface="Cambria" pitchFamily="34" charset="-122"/>
+                <a:cs typeface="Cambria" pitchFamily="34" charset="-120"/>
+              </a:rPr>
+              <a:t>The measured endpoint is an antibody, not a T cell</a:t>
+            </a:r>
+            <a:endParaRPr lang="en-US" sz="2700" dirty="0"/>
+          </a:p>
+        </p:txBody>
+      </p:sp>
+      <p:pic>
+        <p:nvPicPr>
+          <p:cNvPr id="4" name="Image 0" descr="/home/user/ClaudeCode/hla_ligand_immunogenicity/figures/fig4_tb_coincidence.png">    </p:cNvPr>
+          <p:cNvPicPr>
+            <a:picLocks noChangeAspect="1"/>
+          </p:cNvPicPr>
+          <p:nvPr/>
+        </p:nvPicPr>
+        <p:blipFill>
+          <a:blip r:embed="rId1"/>
+          <a:stretch>
+            <a:fillRect/>
+          </a:stretch>
+        </p:blipFill>
+        <p:spPr>
+          <a:xfrm>
+            <a:off x="566928" y="1115568"/>
+            <a:ext cx="11027664" cy="2834640"/>
+          </a:xfrm>
+          <a:prstGeom prst="rect">
+            <a:avLst/>
+          </a:prstGeom>
+        </p:spPr>
+      </p:pic>
+      <p:sp>
+        <p:nvSpPr>
+          <p:cNvPr id="5" name="Text 2"/>
+          <p:cNvSpPr/>
+          <p:nvPr/>
+        </p:nvSpPr>
+        <p:spPr>
+          <a:xfrm>
+            <a:off x="566928" y="4069080"/>
+            <a:ext cx="11027664" cy="502920"/>
+          </a:xfrm>
+          <a:prstGeom prst="rect">
+            <a:avLst/>
+          </a:prstGeom>
+          <a:noFill/>
+          <a:ln/>
+        </p:spPr>
+        <p:txBody>
+          <a:bodyPr wrap="square" lIns="0" tIns="0" rIns="0" bIns="0" rtlCol="0" anchor="ctr"/>
+          <a:lstStyle/>
+          <a:p>
+            <a:pPr indent="0" marL="0">
+              <a:lnSpc>
+                <a:spcPts val="1600"/>
+              </a:lnSpc>
+              <a:buNone/>
+            </a:pPr>
+            <a:r>
+              <a:rPr lang="en-US" sz="1200" dirty="0">
+                <a:solidFill>
+                  <a:srgbClr val="12212E"/>
+                </a:solidFill>
+                <a:latin typeface="Calibri" pitchFamily="34" charset="0"/>
+                <a:ea typeface="Calibri" pitchFamily="34" charset="-122"/>
+                <a:cs typeface="Calibri" pitchFamily="34" charset="-120"/>
+              </a:rPr>
+              <a:t>A B cell only class-switches with help from a CD4 T cell recognising a peptide from the same protein. The regions worth taking into wet-lab work first are those where a non-self DR cluster and a predicted B-cell epitope coincide — shaded above.</a:t>
+            </a:r>
+            <a:endParaRPr lang="en-US" sz="1200" dirty="0"/>
+          </a:p>
+        </p:txBody>
+      </p:sp>
+      <p:graphicFrame>
+        <p:nvGraphicFramePr>
+          <p:cNvPr id="11" name="Table 0"/>
+          <p:cNvGraphicFramePr>
+            <a:graphicFrameLocks noGrp="1"/>
+          </p:cNvGraphicFramePr>
+          <p:nvPr>
+            <p:extLst>
+              <p:ext uri="{D42A27DB-BD31-4B8C-83A1-F6EECF244321}">
+                <p14:modId xmlns:p14="http://schemas.microsoft.com/office/powerpoint/2010/main" val="1579011935"/>
+              </p:ext>
+            </p:extLst>
+          </p:nvPr>
+        </p:nvGraphicFramePr>
+        <p:xfrm>
+          <a:off x="566928" y="4663440"/>
+          <a:ext cx="11027664" cy="914400"/>
+        </p:xfrm>
+        <a:graphic>
+          <a:graphicData uri="http://schemas.openxmlformats.org/drawingml/2006/table">
+            <a:tbl>
+              <a:tblPr/>
+              <a:tblGrid>
+                <a:gridCol w="1371600"/>
+                <a:gridCol w="1188720"/>
+                <a:gridCol w="1554480"/>
+                <a:gridCol w="1371600"/>
+                <a:gridCol w="1097280"/>
+                <a:gridCol w="4443984"/>
+              </a:tblGrid>
+              <a:tr h="292608">
+                <a:tc>
+                  <a:txBody>
+                    <a:bodyPr/>
+                    <a:lstStyle/>
+                    <a:p>
+                      <a:pPr indent="0" marL="0">
+                        <a:buNone/>
+                      </a:pPr>
+                      <a:r>
+                        <a:rPr lang="en-US" sz="850" b="1" spc="60" kern="0" dirty="0">
+                          <a:solidFill>
+                            <a:srgbClr val="63748A"/>
+                          </a:solidFill>
+                          <a:latin typeface="Calibri" pitchFamily="34" charset="0"/>
+                          <a:ea typeface="Calibri" pitchFamily="34" charset="-122"/>
+                          <a:cs typeface="Calibri" pitchFamily="34" charset="-120"/>
+                        </a:rPr>
+                        <a:t>T-cell cluster</a:t>
+                      </a:r>
+                      <a:endParaRPr lang="en-US" sz="850" dirty="0">
+                        <a:latin typeface="Calibri" charset="0"/>
+                        <a:ea typeface="Calibri" charset="0"/>
+                        <a:cs typeface="Calibri" charset="0"/>
+                      </a:endParaRPr>
+                    </a:p>
+                  </a:txBody>
+                  <a:tcPr marL="91440" marR="91440" marT="45720" marB="45720" anchor="ctr">
+                    <a:lnL w="6350" cap="flat" cmpd="sng" algn="ctr">
+                      <a:solidFill>
+                        <a:srgbClr val="DCE4EC"/>
+                      </a:solidFill>
+                      <a:prstDash val="solid"/>
+                      <a:round/>
+                      <a:headEnd type="none" w="med" len="med"/>
+                      <a:tailEnd type="none" w="med" len="med"/>
+                    </a:lnL>
+                    <a:lnR w="6350" cap="flat" cmpd="sng" algn="ctr">
+                      <a:solidFill>
+                        <a:srgbClr val="DCE4EC"/>
+                      </a:solidFill>
+                      <a:prstDash val="solid"/>
+                      <a:round/>
+                      <a:headEnd type="none" w="med" len="med"/>
+                      <a:tailEnd type="none" w="med" len="med"/>
+                    </a:lnR>
+                    <a:lnT w="6350" cap="flat" cmpd="sng" algn="ctr">
+                      <a:solidFill>
+                        <a:srgbClr val="DCE4EC"/>
+                      </a:solidFill>
+                      <a:prstDash val="solid"/>
+                      <a:round/>
+                      <a:headEnd type="none" w="med" len="med"/>
+                      <a:tailEnd type="none" w="med" len="med"/>
+                    </a:lnT>
+                    <a:lnB w="6350" cap="flat" cmpd="sng" algn="ctr">
+                      <a:solidFill>
+                        <a:srgbClr val="DCE4EC"/>
+                      </a:solidFill>
+                      <a:prstDash val="solid"/>
+                      <a:round/>
+                      <a:headEnd type="none" w="med" len="med"/>
+                      <a:tailEnd type="none" w="med" len="med"/>
+                    </a:lnB>
+                    <a:solidFill>
+                      <a:srgbClr val="F2F6F9"/>
+                    </a:solidFill>
+                  </a:tcPr>
+                </a:tc>
+                <a:tc>
+                  <a:txBody>
+                    <a:bodyPr/>
+                    <a:lstStyle/>
+                    <a:p>
+                      <a:pPr indent="0" marL="0">
+                        <a:buNone/>
+                      </a:pPr>
+                      <a:r>
+                        <a:rPr lang="en-US" sz="850" b="1" spc="60" kern="0" dirty="0">
+                          <a:solidFill>
+                            <a:srgbClr val="63748A"/>
+                          </a:solidFill>
+                          <a:latin typeface="Calibri" pitchFamily="34" charset="0"/>
+                          <a:ea typeface="Calibri" pitchFamily="34" charset="-122"/>
+                          <a:cs typeface="Calibri" pitchFamily="34" charset="-120"/>
+                        </a:rPr>
+                        <a:t>Core</a:t>
+                      </a:r>
+                      <a:endParaRPr lang="en-US" sz="850" dirty="0">
+                        <a:latin typeface="Calibri" charset="0"/>
+                        <a:ea typeface="Calibri" charset="0"/>
+                        <a:cs typeface="Calibri" charset="0"/>
+                      </a:endParaRPr>
+                    </a:p>
+                  </a:txBody>
+                  <a:tcPr marL="91440" marR="91440" marT="45720" marB="45720" anchor="ctr">
+                    <a:lnL w="6350" cap="flat" cmpd="sng" algn="ctr">
+                      <a:solidFill>
+                        <a:srgbClr val="DCE4EC"/>
+                      </a:solidFill>
+                      <a:prstDash val="solid"/>
+                      <a:round/>
+                      <a:headEnd type="none" w="med" len="med"/>
+                      <a:tailEnd type="none" w="med" len="med"/>
+                    </a:lnL>
+                    <a:lnR w="6350" cap="flat" cmpd="sng" algn="ctr">
+                      <a:solidFill>
+                        <a:srgbClr val="DCE4EC"/>
+                      </a:solidFill>
+                      <a:prstDash val="solid"/>
+                      <a:round/>
+                      <a:headEnd type="none" w="med" len="med"/>
+                      <a:tailEnd type="none" w="med" len="med"/>
+                    </a:lnR>
+                    <a:lnT w="6350" cap="flat" cmpd="sng" algn="ctr">
+                      <a:solidFill>
+                        <a:srgbClr val="DCE4EC"/>
+                      </a:solidFill>
+                      <a:prstDash val="solid"/>
+                      <a:round/>
+                      <a:headEnd type="none" w="med" len="med"/>
+                      <a:tailEnd type="none" w="med" len="med"/>
+                    </a:lnT>
+                    <a:lnB w="6350" cap="flat" cmpd="sng" algn="ctr">
+                      <a:solidFill>
+                        <a:srgbClr val="DCE4EC"/>
+                      </a:solidFill>
+                      <a:prstDash val="solid"/>
+                      <a:round/>
+                      <a:headEnd type="none" w="med" len="med"/>
+                      <a:tailEnd type="none" w="med" len="med"/>
+                    </a:lnB>
+                    <a:solidFill>
+                      <a:srgbClr val="F2F6F9"/>
+                    </a:solidFill>
+                  </a:tcPr>
+                </a:tc>
+                <a:tc>
+                  <a:txBody>
+                    <a:bodyPr/>
+                    <a:lstStyle/>
+                    <a:p>
+                      <a:pPr indent="0" marL="0">
+                        <a:buNone/>
+                      </a:pPr>
+                      <a:r>
+                        <a:rPr lang="en-US" sz="850" b="1" spc="60" kern="0" dirty="0">
+                          <a:solidFill>
+                            <a:srgbClr val="63748A"/>
+                          </a:solidFill>
+                          <a:latin typeface="Calibri" pitchFamily="34" charset="0"/>
+                          <a:ea typeface="Calibri" pitchFamily="34" charset="-122"/>
+                          <a:cs typeface="Calibri" pitchFamily="34" charset="-120"/>
+                        </a:rPr>
+                        <a:t>% pop presenting</a:t>
+                      </a:r>
+                      <a:endParaRPr lang="en-US" sz="850" dirty="0">
+                        <a:latin typeface="Calibri" charset="0"/>
+                        <a:ea typeface="Calibri" charset="0"/>
+                        <a:cs typeface="Calibri" charset="0"/>
+                      </a:endParaRPr>
+                    </a:p>
+                  </a:txBody>
+                  <a:tcPr marL="91440" marR="91440" marT="45720" marB="45720" anchor="ctr">
+                    <a:lnL w="6350" cap="flat" cmpd="sng" algn="ctr">
+                      <a:solidFill>
+                        <a:srgbClr val="DCE4EC"/>
+                      </a:solidFill>
+                      <a:prstDash val="solid"/>
+                      <a:round/>
+                      <a:headEnd type="none" w="med" len="med"/>
+                      <a:tailEnd type="none" w="med" len="med"/>
+                    </a:lnL>
+                    <a:lnR w="6350" cap="flat" cmpd="sng" algn="ctr">
+                      <a:solidFill>
+                        <a:srgbClr val="DCE4EC"/>
+                      </a:solidFill>
+                      <a:prstDash val="solid"/>
+                      <a:round/>
+                      <a:headEnd type="none" w="med" len="med"/>
+                      <a:tailEnd type="none" w="med" len="med"/>
+                    </a:lnR>
+                    <a:lnT w="6350" cap="flat" cmpd="sng" algn="ctr">
+                      <a:solidFill>
+                        <a:srgbClr val="DCE4EC"/>
+                      </a:solidFill>
+                      <a:prstDash val="solid"/>
+                      <a:round/>
+                      <a:headEnd type="none" w="med" len="med"/>
+                      <a:tailEnd type="none" w="med" len="med"/>
+                    </a:lnT>
+                    <a:lnB w="6350" cap="flat" cmpd="sng" algn="ctr">
+                      <a:solidFill>
+                        <a:srgbClr val="DCE4EC"/>
+                      </a:solidFill>
+                      <a:prstDash val="solid"/>
+                      <a:round/>
+                      <a:headEnd type="none" w="med" len="med"/>
+                      <a:tailEnd type="none" w="med" len="med"/>
+                    </a:lnB>
+                    <a:solidFill>
+                      <a:srgbClr val="F2F6F9"/>
+                    </a:solidFill>
+                  </a:tcPr>
+                </a:tc>
+                <a:tc>
+                  <a:txBody>
+                    <a:bodyPr/>
+                    <a:lstStyle/>
+                    <a:p>
+                      <a:pPr indent="0" marL="0">
+                        <a:buNone/>
+                      </a:pPr>
+                      <a:r>
+                        <a:rPr lang="en-US" sz="850" b="1" spc="60" kern="0" dirty="0">
+                          <a:solidFill>
+                            <a:srgbClr val="63748A"/>
+                          </a:solidFill>
+                          <a:latin typeface="Calibri" pitchFamily="34" charset="0"/>
+                          <a:ea typeface="Calibri" pitchFamily="34" charset="-122"/>
+                          <a:cs typeface="Calibri" pitchFamily="34" charset="-120"/>
+                        </a:rPr>
+                        <a:t>B-cell region</a:t>
+                      </a:r>
+                      <a:endParaRPr lang="en-US" sz="850" dirty="0">
+                        <a:latin typeface="Calibri" charset="0"/>
+                        <a:ea typeface="Calibri" charset="0"/>
+                        <a:cs typeface="Calibri" charset="0"/>
+                      </a:endParaRPr>
+                    </a:p>
+                  </a:txBody>
+                  <a:tcPr marL="91440" marR="91440" marT="45720" marB="45720" anchor="ctr">
+                    <a:lnL w="6350" cap="flat" cmpd="sng" algn="ctr">
+                      <a:solidFill>
+                        <a:srgbClr val="DCE4EC"/>
+                      </a:solidFill>
+                      <a:prstDash val="solid"/>
+                      <a:round/>
+                      <a:headEnd type="none" w="med" len="med"/>
+                      <a:tailEnd type="none" w="med" len="med"/>
+                    </a:lnL>
+                    <a:lnR w="6350" cap="flat" cmpd="sng" algn="ctr">
+                      <a:solidFill>
+                        <a:srgbClr val="DCE4EC"/>
+                      </a:solidFill>
+                      <a:prstDash val="solid"/>
+                      <a:round/>
+                      <a:headEnd type="none" w="med" len="med"/>
+                      <a:tailEnd type="none" w="med" len="med"/>
+                    </a:lnR>
+                    <a:lnT w="6350" cap="flat" cmpd="sng" algn="ctr">
+                      <a:solidFill>
+                        <a:srgbClr val="DCE4EC"/>
+                      </a:solidFill>
+                      <a:prstDash val="solid"/>
+                      <a:round/>
+                      <a:headEnd type="none" w="med" len="med"/>
+                      <a:tailEnd type="none" w="med" len="med"/>
+                    </a:lnT>
+                    <a:lnB w="6350" cap="flat" cmpd="sng" algn="ctr">
+                      <a:solidFill>
+                        <a:srgbClr val="DCE4EC"/>
+                      </a:solidFill>
+                      <a:prstDash val="solid"/>
+                      <a:round/>
+                      <a:headEnd type="none" w="med" len="med"/>
+                      <a:tailEnd type="none" w="med" len="med"/>
+                    </a:lnB>
+                    <a:solidFill>
+                      <a:srgbClr val="F2F6F9"/>
+                    </a:solidFill>
+                  </a:tcPr>
+                </a:tc>
+                <a:tc>
+                  <a:txBody>
+                    <a:bodyPr/>
+                    <a:lstStyle/>
+                    <a:p>
+                      <a:pPr indent="0" marL="0">
+                        <a:buNone/>
+                      </a:pPr>
+                      <a:r>
+                        <a:rPr lang="en-US" sz="850" b="1" spc="60" kern="0" dirty="0">
+                          <a:solidFill>
+                            <a:srgbClr val="63748A"/>
+                          </a:solidFill>
+                          <a:latin typeface="Calibri" pitchFamily="34" charset="0"/>
+                          <a:ea typeface="Calibri" pitchFamily="34" charset="-122"/>
+                          <a:cs typeface="Calibri" pitchFamily="34" charset="-120"/>
+                        </a:rPr>
+                        <a:t>Overlap (aa)</a:t>
+                      </a:r>
+                      <a:endParaRPr lang="en-US" sz="850" dirty="0">
+                        <a:latin typeface="Calibri" charset="0"/>
+                        <a:ea typeface="Calibri" charset="0"/>
+                        <a:cs typeface="Calibri" charset="0"/>
+                      </a:endParaRPr>
+                    </a:p>
+                  </a:txBody>
+                  <a:tcPr marL="91440" marR="91440" marT="45720" marB="45720" anchor="ctr">
+                    <a:lnL w="6350" cap="flat" cmpd="sng" algn="ctr">
+                      <a:solidFill>
+                        <a:srgbClr val="DCE4EC"/>
+                      </a:solidFill>
+                      <a:prstDash val="solid"/>
+                      <a:round/>
+                      <a:headEnd type="none" w="med" len="med"/>
+                      <a:tailEnd type="none" w="med" len="med"/>
+                    </a:lnL>
+                    <a:lnR w="6350" cap="flat" cmpd="sng" algn="ctr">
+                      <a:solidFill>
+                        <a:srgbClr val="DCE4EC"/>
+                      </a:solidFill>
+                      <a:prstDash val="solid"/>
+                      <a:round/>
+                      <a:headEnd type="none" w="med" len="med"/>
+                      <a:tailEnd type="none" w="med" len="med"/>
+                    </a:lnR>
+                    <a:lnT w="6350" cap="flat" cmpd="sng" algn="ctr">
+                      <a:solidFill>
+                        <a:srgbClr val="DCE4EC"/>
+                      </a:solidFill>
+                      <a:prstDash val="solid"/>
+                      <a:round/>
+                      <a:headEnd type="none" w="med" len="med"/>
+                      <a:tailEnd type="none" w="med" len="med"/>
+                    </a:lnT>
+                    <a:lnB w="6350" cap="flat" cmpd="sng" algn="ctr">
+                      <a:solidFill>
+                        <a:srgbClr val="DCE4EC"/>
+                      </a:solidFill>
+                      <a:prstDash val="solid"/>
+                      <a:round/>
+                      <a:headEnd type="none" w="med" len="med"/>
+                      <a:tailEnd type="none" w="med" len="med"/>
+                    </a:lnB>
+                    <a:solidFill>
+                      <a:srgbClr val="F2F6F9"/>
+                    </a:solidFill>
+                  </a:tcPr>
+                </a:tc>
+                <a:tc>
+                  <a:txBody>
+                    <a:bodyPr/>
+                    <a:lstStyle/>
+                    <a:p>
+                      <a:pPr indent="0" marL="0">
+                        <a:buNone/>
+                      </a:pPr>
+                      <a:r>
+                        <a:rPr lang="en-US" sz="850" b="1" spc="60" kern="0" dirty="0">
+                          <a:solidFill>
+                            <a:srgbClr val="63748A"/>
+                          </a:solidFill>
+                          <a:latin typeface="Calibri" pitchFamily="34" charset="0"/>
+                          <a:ea typeface="Calibri" pitchFamily="34" charset="-122"/>
+                          <a:cs typeface="Calibri" pitchFamily="34" charset="-120"/>
+                        </a:rPr>
+                        <a:t>Region sequence</a:t>
+                      </a:r>
+                      <a:endParaRPr lang="en-US" sz="850" dirty="0">
+                        <a:latin typeface="Calibri" charset="0"/>
+                        <a:ea typeface="Calibri" charset="0"/>
+                        <a:cs typeface="Calibri" charset="0"/>
+                      </a:endParaRPr>
+                    </a:p>
+                  </a:txBody>
+                  <a:tcPr marL="91440" marR="91440" marT="45720" marB="45720" anchor="ctr">
+                    <a:lnL w="6350" cap="flat" cmpd="sng" algn="ctr">
+                      <a:solidFill>
+                        <a:srgbClr val="DCE4EC"/>
+                      </a:solidFill>
+                      <a:prstDash val="solid"/>
+                      <a:round/>
+                      <a:headEnd type="none" w="med" len="med"/>
+                      <a:tailEnd type="none" w="med" len="med"/>
+                    </a:lnL>
+                    <a:lnR w="6350" cap="flat" cmpd="sng" algn="ctr">
+                      <a:solidFill>
+                        <a:srgbClr val="DCE4EC"/>
+                      </a:solidFill>
+                      <a:prstDash val="solid"/>
+                      <a:round/>
+                      <a:headEnd type="none" w="med" len="med"/>
+                      <a:tailEnd type="none" w="med" len="med"/>
+                    </a:lnR>
+                    <a:lnT w="6350" cap="flat" cmpd="sng" algn="ctr">
+                      <a:solidFill>
+                        <a:srgbClr val="DCE4EC"/>
+                      </a:solidFill>
+                      <a:prstDash val="solid"/>
+                      <a:round/>
+                      <a:headEnd type="none" w="med" len="med"/>
+                      <a:tailEnd type="none" w="med" len="med"/>
+                    </a:lnT>
+                    <a:lnB w="6350" cap="flat" cmpd="sng" algn="ctr">
+                      <a:solidFill>
+                        <a:srgbClr val="DCE4EC"/>
+                      </a:solidFill>
+                      <a:prstDash val="solid"/>
+                      <a:round/>
+                      <a:headEnd type="none" w="med" len="med"/>
+                      <a:tailEnd type="none" w="med" len="med"/>
+                    </a:lnB>
+                    <a:solidFill>
+                      <a:srgbClr val="F2F6F9"/>
+                    </a:solidFill>
+                  </a:tcPr>
+                </a:tc>
+              </a:tr>
+              <a:tr h="292608">
+                <a:tc>
+                  <a:txBody>
+                    <a:bodyPr/>
+                    <a:lstStyle/>
+                    <a:p>
+                      <a:pPr indent="0" marL="0">
+                        <a:buNone/>
+                      </a:pPr>
+                      <a:r>
+                        <a:rPr lang="en-US" sz="1000" dirty="0">
+                          <a:solidFill>
+                            <a:srgbClr val="12212E"/>
+                          </a:solidFill>
+                          <a:latin typeface="Calibri" pitchFamily="34" charset="0"/>
+                          <a:ea typeface="Calibri" pitchFamily="34" charset="-122"/>
+                          <a:cs typeface="Calibri" pitchFamily="34" charset="-120"/>
+                        </a:rPr>
+                        <a:t>47-56</a:t>
+                      </a:r>
+                      <a:endParaRPr lang="en-US" sz="1000" dirty="0">
+                        <a:latin typeface="Calibri" charset="0"/>
+                        <a:ea typeface="Calibri" charset="0"/>
+                        <a:cs typeface="Calibri" charset="0"/>
+                      </a:endParaRPr>
+                    </a:p>
+                  </a:txBody>
+                  <a:tcPr marL="91440" marR="91440" marT="45720" marB="45720" anchor="ctr">
+                    <a:lnL w="6350" cap="flat" cmpd="sng" algn="ctr">
+                      <a:solidFill>
+                        <a:srgbClr val="DCE4EC"/>
+                      </a:solidFill>
+                      <a:prstDash val="solid"/>
+                      <a:round/>
+                      <a:headEnd type="none" w="med" len="med"/>
+                      <a:tailEnd type="none" w="med" len="med"/>
+                    </a:lnL>
+                    <a:lnR w="6350" cap="flat" cmpd="sng" algn="ctr">
+                      <a:solidFill>
+                        <a:srgbClr val="DCE4EC"/>
+                      </a:solidFill>
+                      <a:prstDash val="solid"/>
+                      <a:round/>
+                      <a:headEnd type="none" w="med" len="med"/>
+                      <a:tailEnd type="none" w="med" len="med"/>
+                    </a:lnR>
+                    <a:lnT w="6350" cap="flat" cmpd="sng" algn="ctr">
+                      <a:solidFill>
+                        <a:srgbClr val="DCE4EC"/>
+                      </a:solidFill>
+                      <a:prstDash val="solid"/>
+                      <a:round/>
+                      <a:headEnd type="none" w="med" len="med"/>
+                      <a:tailEnd type="none" w="med" len="med"/>
+                    </a:lnT>
+                    <a:lnB w="6350" cap="flat" cmpd="sng" algn="ctr">
+                      <a:solidFill>
+                        <a:srgbClr val="DCE4EC"/>
+                      </a:solidFill>
+                      <a:prstDash val="solid"/>
+                      <a:round/>
+                      <a:headEnd type="none" w="med" len="med"/>
+                      <a:tailEnd type="none" w="med" len="med"/>
+                    </a:lnB>
+                  </a:tcPr>
+                </a:tc>
+                <a:tc>
+                  <a:txBody>
+                    <a:bodyPr/>
+                    <a:lstStyle/>
+                    <a:p>
+                      <a:pPr indent="0" marL="0">
+                        <a:buNone/>
+                      </a:pPr>
+                      <a:r>
+                        <a:rPr lang="en-US" sz="1000" b="1" dirty="0">
+                          <a:solidFill>
+                            <a:srgbClr val="12212E"/>
+                          </a:solidFill>
+                          <a:latin typeface="Courier New" pitchFamily="34" charset="0"/>
+                          <a:ea typeface="Courier New" pitchFamily="34" charset="-122"/>
+                          <a:cs typeface="Courier New" pitchFamily="34" charset="-120"/>
+                        </a:rPr>
+                        <a:t>FVAVQDITA</a:t>
+                      </a:r>
+                      <a:endParaRPr lang="en-US" sz="1000" dirty="0">
+                        <a:latin typeface="Courier New" charset="0"/>
+                        <a:ea typeface="Courier New" charset="0"/>
+                        <a:cs typeface="Courier New" charset="0"/>
+                      </a:endParaRPr>
+                    </a:p>
+                  </a:txBody>
+                  <a:tcPr marL="91440" marR="91440" marT="45720" marB="45720" anchor="ctr">
+                    <a:lnL w="6350" cap="flat" cmpd="sng" algn="ctr">
+                      <a:solidFill>
+                        <a:srgbClr val="DCE4EC"/>
+                      </a:solidFill>
+                      <a:prstDash val="solid"/>
+                      <a:round/>
+                      <a:headEnd type="none" w="med" len="med"/>
+                      <a:tailEnd type="none" w="med" len="med"/>
+                    </a:lnL>
+                    <a:lnR w="6350" cap="flat" cmpd="sng" algn="ctr">
+                      <a:solidFill>
+                        <a:srgbClr val="DCE4EC"/>
+                      </a:solidFill>
+                      <a:prstDash val="solid"/>
+                      <a:round/>
+                      <a:headEnd type="none" w="med" len="med"/>
+                      <a:tailEnd type="none" w="med" len="med"/>
+                    </a:lnR>
+                    <a:lnT w="6350" cap="flat" cmpd="sng" algn="ctr">
+                      <a:solidFill>
+                        <a:srgbClr val="DCE4EC"/>
+                      </a:solidFill>
+                      <a:prstDash val="solid"/>
+                      <a:round/>
+                      <a:headEnd type="none" w="med" len="med"/>
+                      <a:tailEnd type="none" w="med" len="med"/>
+                    </a:lnT>
+                    <a:lnB w="6350" cap="flat" cmpd="sng" algn="ctr">
+                      <a:solidFill>
+                        <a:srgbClr val="DCE4EC"/>
+                      </a:solidFill>
+                      <a:prstDash val="solid"/>
+                      <a:round/>
+                      <a:headEnd type="none" w="med" len="med"/>
+                      <a:tailEnd type="none" w="med" len="med"/>
+                    </a:lnB>
+                  </a:tcPr>
+                </a:tc>
+                <a:tc>
+                  <a:txBody>
+                    <a:bodyPr/>
+                    <a:lstStyle/>
+                    <a:p>
+                      <a:pPr algn="r" indent="0" marL="0">
+                        <a:buNone/>
+                      </a:pPr>
+                      <a:r>
+                        <a:rPr lang="en-US" sz="1000" b="1" dirty="0">
+                          <a:solidFill>
+                            <a:srgbClr val="12212E"/>
+                          </a:solidFill>
+                          <a:latin typeface="Calibri" pitchFamily="34" charset="0"/>
+                          <a:ea typeface="Calibri" pitchFamily="34" charset="-122"/>
+                          <a:cs typeface="Calibri" pitchFamily="34" charset="-120"/>
+                        </a:rPr>
+                        <a:t>28.5%</a:t>
+                      </a:r>
+                      <a:endParaRPr lang="en-US" sz="1000" dirty="0">
+                        <a:latin typeface="Calibri" charset="0"/>
+                        <a:ea typeface="Calibri" charset="0"/>
+                        <a:cs typeface="Calibri" charset="0"/>
+                      </a:endParaRPr>
+                    </a:p>
+                  </a:txBody>
+                  <a:tcPr marL="91440" marR="91440" marT="45720" marB="45720" anchor="ctr">
+                    <a:lnL w="6350" cap="flat" cmpd="sng" algn="ctr">
+                      <a:solidFill>
+                        <a:srgbClr val="DCE4EC"/>
+                      </a:solidFill>
+                      <a:prstDash val="solid"/>
+                      <a:round/>
+                      <a:headEnd type="none" w="med" len="med"/>
+                      <a:tailEnd type="none" w="med" len="med"/>
+                    </a:lnL>
+                    <a:lnR w="6350" cap="flat" cmpd="sng" algn="ctr">
+                      <a:solidFill>
+                        <a:srgbClr val="DCE4EC"/>
+                      </a:solidFill>
+                      <a:prstDash val="solid"/>
+                      <a:round/>
+                      <a:headEnd type="none" w="med" len="med"/>
+                      <a:tailEnd type="none" w="med" len="med"/>
+                    </a:lnR>
+                    <a:lnT w="6350" cap="flat" cmpd="sng" algn="ctr">
+                      <a:solidFill>
+                        <a:srgbClr val="DCE4EC"/>
+                      </a:solidFill>
+                      <a:prstDash val="solid"/>
+                      <a:round/>
+                      <a:headEnd type="none" w="med" len="med"/>
+                      <a:tailEnd type="none" w="med" len="med"/>
+                    </a:lnT>
+                    <a:lnB w="6350" cap="flat" cmpd="sng" algn="ctr">
+                      <a:solidFill>
+                        <a:srgbClr val="DCE4EC"/>
+                      </a:solidFill>
+                      <a:prstDash val="solid"/>
+                      <a:round/>
+                      <a:headEnd type="none" w="med" len="med"/>
+                      <a:tailEnd type="none" w="med" len="med"/>
+                    </a:lnB>
+                  </a:tcPr>
+                </a:tc>
+                <a:tc>
+                  <a:txBody>
+                    <a:bodyPr/>
+                    <a:lstStyle/>
+                    <a:p>
+                      <a:pPr indent="0" marL="0">
+                        <a:buNone/>
+                      </a:pPr>
+                      <a:r>
+                        <a:rPr lang="en-US" sz="1000" dirty="0">
+                          <a:solidFill>
+                            <a:srgbClr val="12212E"/>
+                          </a:solidFill>
+                          <a:latin typeface="Calibri" pitchFamily="34" charset="0"/>
+                          <a:ea typeface="Calibri" pitchFamily="34" charset="-122"/>
+                          <a:cs typeface="Calibri" pitchFamily="34" charset="-120"/>
+                        </a:rPr>
+                        <a:t>53-63</a:t>
+                      </a:r>
+                      <a:endParaRPr lang="en-US" sz="1000" dirty="0">
+                        <a:latin typeface="Calibri" charset="0"/>
+                        <a:ea typeface="Calibri" charset="0"/>
+                        <a:cs typeface="Calibri" charset="0"/>
+                      </a:endParaRPr>
+                    </a:p>
+                  </a:txBody>
+                  <a:tcPr marL="91440" marR="91440" marT="45720" marB="45720" anchor="ctr">
+                    <a:lnL w="6350" cap="flat" cmpd="sng" algn="ctr">
+                      <a:solidFill>
+                        <a:srgbClr val="DCE4EC"/>
+                      </a:solidFill>
+                      <a:prstDash val="solid"/>
+                      <a:round/>
+                      <a:headEnd type="none" w="med" len="med"/>
+                      <a:tailEnd type="none" w="med" len="med"/>
+                    </a:lnL>
+                    <a:lnR w="6350" cap="flat" cmpd="sng" algn="ctr">
+                      <a:solidFill>
+                        <a:srgbClr val="DCE4EC"/>
+                      </a:solidFill>
+                      <a:prstDash val="solid"/>
+                      <a:round/>
+                      <a:headEnd type="none" w="med" len="med"/>
+                      <a:tailEnd type="none" w="med" len="med"/>
+                    </a:lnR>
+                    <a:lnT w="6350" cap="flat" cmpd="sng" algn="ctr">
+                      <a:solidFill>
+                        <a:srgbClr val="DCE4EC"/>
+                      </a:solidFill>
+                      <a:prstDash val="solid"/>
+                      <a:round/>
+                      <a:headEnd type="none" w="med" len="med"/>
+                      <a:tailEnd type="none" w="med" len="med"/>
+                    </a:lnT>
+                    <a:lnB w="6350" cap="flat" cmpd="sng" algn="ctr">
+                      <a:solidFill>
+                        <a:srgbClr val="DCE4EC"/>
+                      </a:solidFill>
+                      <a:prstDash val="solid"/>
+                      <a:round/>
+                      <a:headEnd type="none" w="med" len="med"/>
+                      <a:tailEnd type="none" w="med" len="med"/>
+                    </a:lnB>
+                  </a:tcPr>
+                </a:tc>
+                <a:tc>
+                  <a:txBody>
+                    <a:bodyPr/>
+                    <a:lstStyle/>
+                    <a:p>
+                      <a:pPr algn="r" indent="0" marL="0">
+                        <a:buNone/>
+                      </a:pPr>
+                      <a:r>
+                        <a:rPr lang="en-US" sz="1000" dirty="0">
+                          <a:solidFill>
+                            <a:srgbClr val="12212E"/>
+                          </a:solidFill>
+                          <a:latin typeface="Calibri" pitchFamily="34" charset="0"/>
+                          <a:ea typeface="Calibri" pitchFamily="34" charset="-122"/>
+                          <a:cs typeface="Calibri" pitchFamily="34" charset="-120"/>
+                        </a:rPr>
+                        <a:t>4</a:t>
+                      </a:r>
+                      <a:endParaRPr lang="en-US" sz="1000" dirty="0">
+                        <a:latin typeface="Calibri" charset="0"/>
+                        <a:ea typeface="Calibri" charset="0"/>
+                        <a:cs typeface="Calibri" charset="0"/>
+                      </a:endParaRPr>
+                    </a:p>
+                  </a:txBody>
+                  <a:tcPr marL="91440" marR="91440" marT="45720" marB="45720" anchor="ctr">
+                    <a:lnL w="6350" cap="flat" cmpd="sng" algn="ctr">
+                      <a:solidFill>
+                        <a:srgbClr val="DCE4EC"/>
+                      </a:solidFill>
+                      <a:prstDash val="solid"/>
+                      <a:round/>
+                      <a:headEnd type="none" w="med" len="med"/>
+                      <a:tailEnd type="none" w="med" len="med"/>
+                    </a:lnL>
+                    <a:lnR w="6350" cap="flat" cmpd="sng" algn="ctr">
+                      <a:solidFill>
+                        <a:srgbClr val="DCE4EC"/>
+                      </a:solidFill>
+                      <a:prstDash val="solid"/>
+                      <a:round/>
+                      <a:headEnd type="none" w="med" len="med"/>
+                      <a:tailEnd type="none" w="med" len="med"/>
+                    </a:lnR>
+                    <a:lnT w="6350" cap="flat" cmpd="sng" algn="ctr">
+                      <a:solidFill>
+                        <a:srgbClr val="DCE4EC"/>
+                      </a:solidFill>
+                      <a:prstDash val="solid"/>
+                      <a:round/>
+                      <a:headEnd type="none" w="med" len="med"/>
+                      <a:tailEnd type="none" w="med" len="med"/>
+                    </a:lnT>
+                    <a:lnB w="6350" cap="flat" cmpd="sng" algn="ctr">
+                      <a:solidFill>
+                        <a:srgbClr val="DCE4EC"/>
+                      </a:solidFill>
+                      <a:prstDash val="solid"/>
+                      <a:round/>
+                      <a:headEnd type="none" w="med" len="med"/>
+                      <a:tailEnd type="none" w="med" len="med"/>
+                    </a:lnB>
+                  </a:tcPr>
+                </a:tc>
+                <a:tc>
+                  <a:txBody>
+                    <a:bodyPr/>
+                    <a:lstStyle/>
+                    <a:p>
+                      <a:pPr indent="0" marL="0">
+                        <a:buNone/>
+                      </a:pPr>
+                      <a:r>
+                        <a:rPr lang="en-US" sz="850" dirty="0">
+                          <a:solidFill>
+                            <a:srgbClr val="12212E"/>
+                          </a:solidFill>
+                          <a:latin typeface="Courier New" pitchFamily="34" charset="0"/>
+                          <a:ea typeface="Courier New" pitchFamily="34" charset="-122"/>
+                          <a:cs typeface="Courier New" pitchFamily="34" charset="-120"/>
+                        </a:rPr>
+                        <a:t>ITASNTHYSSA</a:t>
+                      </a:r>
+                      <a:endParaRPr lang="en-US" sz="850" dirty="0">
+                        <a:latin typeface="Courier New" charset="0"/>
+                        <a:ea typeface="Courier New" charset="0"/>
+                        <a:cs typeface="Courier New" charset="0"/>
+                      </a:endParaRPr>
+                    </a:p>
+                  </a:txBody>
+                  <a:tcPr marL="91440" marR="91440" marT="45720" marB="45720" anchor="ctr">
+                    <a:lnL w="6350" cap="flat" cmpd="sng" algn="ctr">
+                      <a:solidFill>
+                        <a:srgbClr val="DCE4EC"/>
+                      </a:solidFill>
+                      <a:prstDash val="solid"/>
+                      <a:round/>
+                      <a:headEnd type="none" w="med" len="med"/>
+                      <a:tailEnd type="none" w="med" len="med"/>
+                    </a:lnL>
+                    <a:lnR w="6350" cap="flat" cmpd="sng" algn="ctr">
+                      <a:solidFill>
+                        <a:srgbClr val="DCE4EC"/>
+                      </a:solidFill>
+                      <a:prstDash val="solid"/>
+                      <a:round/>
+                      <a:headEnd type="none" w="med" len="med"/>
+                      <a:tailEnd type="none" w="med" len="med"/>
+                    </a:lnR>
+                    <a:lnT w="6350" cap="flat" cmpd="sng" algn="ctr">
+                      <a:solidFill>
+                        <a:srgbClr val="DCE4EC"/>
+                      </a:solidFill>
+                      <a:prstDash val="solid"/>
+                      <a:round/>
+                      <a:headEnd type="none" w="med" len="med"/>
+                      <a:tailEnd type="none" w="med" len="med"/>
+                    </a:lnT>
+                    <a:lnB w="6350" cap="flat" cmpd="sng" algn="ctr">
+                      <a:solidFill>
+                        <a:srgbClr val="DCE4EC"/>
+                      </a:solidFill>
+                      <a:prstDash val="solid"/>
+                      <a:round/>
+                      <a:headEnd type="none" w="med" len="med"/>
+                      <a:tailEnd type="none" w="med" len="med"/>
+                    </a:lnB>
+                  </a:tcPr>
+                </a:tc>
+              </a:tr>
+            </a:tbl>
+          </a:graphicData>
+        </a:graphic>
+      </p:graphicFrame>
+      <p:sp>
+        <p:nvSpPr>
+          <p:cNvPr id="7" name="Text 3"/>
+          <p:cNvSpPr/>
+          <p:nvPr/>
+        </p:nvSpPr>
+        <p:spPr>
+          <a:xfrm>
+            <a:off x="566928" y="6172200"/>
+            <a:ext cx="11027664" cy="502920"/>
+          </a:xfrm>
+          <a:prstGeom prst="rect">
+            <a:avLst/>
+          </a:prstGeom>
+          <a:noFill/>
+          <a:ln/>
+        </p:spPr>
+        <p:txBody>
+          <a:bodyPr wrap="square" lIns="0" tIns="0" rIns="0" bIns="0" rtlCol="0" anchor="ctr"/>
+          <a:lstStyle/>
+          <a:p>
+            <a:pPr indent="0" marL="0">
+              <a:lnSpc>
+                <a:spcPts val="1200"/>
+              </a:lnSpc>
+              <a:buNone/>
+            </a:pPr>
+            <a:r>
+              <a:rPr lang="en-US" sz="950" i="1" dirty="0">
+                <a:solidFill>
+                  <a:srgbClr val="63748A"/>
+                </a:solidFill>
+                <a:latin typeface="Calibri" pitchFamily="34" charset="0"/>
+                <a:ea typeface="Calibri" pitchFamily="34" charset="-122"/>
+                <a:cs typeface="Calibri" pitchFamily="34" charset="-120"/>
+              </a:rPr>
+              <a:t>BepiPred-2.0 linear B-cell propensity is the weakest model in this pipeline — most real ADA epitopes are conformational. This layer prioritises regions; it is never a standalone claim.</a:t>
+            </a:r>
+            <a:endParaRPr lang="en-US" sz="950" dirty="0"/>
+          </a:p>
+        </p:txBody>
+      </p:sp>
+    </p:spTree>
+  </p:cSld>
+  <p:clrMapOvr>
+    <a:masterClrMapping/>
+  </p:clrMapOvr>
+</p:sld>
+</file>
+
+<file path=ppt/slides/slide11.xml><?xml version="1.0" encoding="utf-8"?>
+<p:sld xmlns:a="http://schemas.openxmlformats.org/drawingml/2006/main" xmlns:r="http://schemas.openxmlformats.org/officeDocument/2006/relationships" xmlns:p="http://schemas.openxmlformats.org/presentationml/2006/main">
+  <p:cSld name="Slide 11">
+    <p:bg>
+      <p:bgPr>
+        <a:solidFill>
+          <a:srgbClr val="FFFFFF"/>
+        </a:solidFill>
+      </p:bgPr>
+    </p:bg>
+    <p:spTree>
+      <p:nvGrpSpPr>
+        <p:cNvPr id="1" name=""/>
+        <p:cNvGrpSpPr/>
+        <p:nvPr/>
+      </p:nvGrpSpPr>
+      <p:grpSpPr>
+        <a:xfrm>
+          <a:off x="0" y="0"/>
+          <a:ext cx="0" cy="0"/>
+          <a:chOff x="0" y="0"/>
+          <a:chExt cx="0" cy="0"/>
+        </a:xfrm>
+      </p:grpSpPr>
+      <p:sp>
+        <p:nvSpPr>
+          <p:cNvPr id="2" name="Text 0"/>
+          <p:cNvSpPr/>
+          <p:nvPr/>
+        </p:nvSpPr>
+        <p:spPr>
+          <a:xfrm>
+            <a:off x="566928" y="310896"/>
+            <a:ext cx="11027664" cy="219456"/>
+          </a:xfrm>
+          <a:prstGeom prst="rect">
+            <a:avLst/>
+          </a:prstGeom>
+          <a:noFill/>
+          <a:ln/>
+        </p:spPr>
+        <p:txBody>
+          <a:bodyPr wrap="square" lIns="0" tIns="0" rIns="0" bIns="0" rtlCol="0" anchor="ctr"/>
+          <a:lstStyle/>
+          <a:p>
+            <a:pPr indent="0" marL="0">
+              <a:buNone/>
+            </a:pPr>
+            <a:r>
+              <a:rPr lang="en-US" sz="1050" b="1" spc="160" kern="0" dirty="0">
+                <a:solidFill>
+                  <a:srgbClr val="2F6F9F"/>
+                </a:solidFill>
+                <a:latin typeface="Calibri" pitchFamily="34" charset="0"/>
+                <a:ea typeface="Calibri" pitchFamily="34" charset="-122"/>
+                <a:cs typeface="Calibri" pitchFamily="34" charset="-120"/>
+              </a:rPr>
               <a:t>MODULE 8 · EXPOSURE CONTEXT</a:t>
             </a:r>
             <a:endParaRPr lang="en-US" sz="1050" dirty="0"/>
@@ -2145,7 +3288,7 @@
       </p:sp>
       <p:graphicFrame>
         <p:nvGraphicFramePr>
-          <p:cNvPr id="11" name="Table 0"/>
+          <p:cNvPr id="12" name="Table 0"/>
           <p:cNvGraphicFramePr>
             <a:graphicFrameLocks noGrp="1"/>
           </p:cNvGraphicFramePr>
@@ -3852,9 +4995,9 @@
 </p:sld>
 </file>
 
-<file path=ppt/slides/slide11.xml><?xml version="1.0" encoding="utf-8"?>
+<file path=ppt/slides/slide12.xml><?xml version="1.0" encoding="utf-8"?>
 <p:sld xmlns:a="http://schemas.openxmlformats.org/drawingml/2006/main" xmlns:r="http://schemas.openxmlformats.org/officeDocument/2006/relationships" xmlns:p="http://schemas.openxmlformats.org/presentationml/2006/main">
-  <p:cSld name="Slide 11">
+  <p:cSld name="Slide 12">
     <p:bg>
       <p:bgPr>
         <a:solidFill>
@@ -4069,7 +5212,7 @@
       </p:sp>
       <p:graphicFrame>
         <p:nvGraphicFramePr>
-          <p:cNvPr id="12" name="Table 0"/>
+          <p:cNvPr id="13" name="Table 0"/>
           <p:cNvGraphicFramePr>
             <a:graphicFrameLocks noGrp="1"/>
           </p:cNvGraphicFramePr>
@@ -8353,9 +9496,9 @@
 </p:sld>
 </file>
 
-<file path=ppt/slides/slide12.xml><?xml version="1.0" encoding="utf-8"?>
+<file path=ppt/slides/slide13.xml><?xml version="1.0" encoding="utf-8"?>
 <p:sld xmlns:a="http://schemas.openxmlformats.org/drawingml/2006/main" xmlns:r="http://schemas.openxmlformats.org/officeDocument/2006/relationships" xmlns:p="http://schemas.openxmlformats.org/presentationml/2006/main">
-  <p:cSld name="Slide 12">
+  <p:cSld name="Slide 13">
     <p:bg>
       <p:bgPr>
         <a:solidFill>
@@ -10242,7 +11385,7 @@
                 <a:ea typeface="Calibri" pitchFamily="34" charset="-122"/>
                 <a:cs typeface="Calibri" pitchFamily="34" charset="-120"/>
               </a:rPr>
-              <a:t>Requiring the binding-affinity head to agree with eluted-ligand scoring removed 16% of strong-binder calls across the batch — peptides that look presented but do not measurably bind.</a:t>
+              <a:t>Requiring the binding-affinity head to agree with eluted-ligand scoring removed 18% of strong-binder calls across the batch — peptides that look presented but do not measurably bind.</a:t>
             </a:r>
             <a:endParaRPr lang="en-US" sz="1150" dirty="0"/>
           </a:p>
@@ -10992,7 +12135,7 @@
                           <a:ea typeface="Calibri" pitchFamily="34" charset="-122"/>
                           <a:cs typeface="Calibri" pitchFamily="34" charset="-120"/>
                         </a:rPr>
-                        <a:t>Eluted-ligand scoring alone over-calls: it rewards motif-like peptides with poor measured affinity. Requiring EL and BA agreement dropped 16% of strong-binder calls.</a:t>
+                        <a:t>Eluted-ligand scoring alone over-calls: it rewards motif-like peptides with poor measured affinity. Requiring EL and BA agreement dropped 18% of strong-binder calls.</a:t>
                       </a:r>
                       <a:endParaRPr lang="en-US" sz="950" dirty="0">
                         <a:latin typeface="Calibri" charset="0"/>
@@ -12122,7 +13265,7 @@
                 <a:ea typeface="Cambria" pitchFamily="34" charset="-122"/>
                 <a:cs typeface="Cambria" pitchFamily="34" charset="-120"/>
               </a:rPr>
-              <a:t>203 → 170   </a:t>
+              <a:t>266 → 218   </a:t>
             </a:r>
             <a:pPr indent="0" marL="0">
               <a:lnSpc>
@@ -12139,7 +13282,7 @@
                 <a:ea typeface="Calibri" pitchFamily="34" charset="-122"/>
                 <a:cs typeface="Calibri" pitchFamily="34" charset="-120"/>
               </a:rPr>
-              <a:t>strong-binder calls across the batch once the binding-affinity head has to agree with eluted-ligand scoring (BA %Rank &lt; 10). 16% of EL-only calls are peptides that look presented but do not measurably bind; every downstream number uses the consensus call.</a:t>
+              <a:t>strong-binder calls across the batch once the binding-affinity head has to agree with eluted-ligand scoring (BA %Rank &lt; 10). 18% of EL-only calls are peptides that look presented but do not measurably bind; every downstream number uses the consensus call.</a:t>
             </a:r>
             <a:endParaRPr lang="en-US" sz="1200" dirty="0"/>
           </a:p>
@@ -12357,7 +13500,7 @@
                 <a:ea typeface="Cambria" pitchFamily="34" charset="-122"/>
                 <a:cs typeface="Cambria" pitchFamily="34" charset="-120"/>
               </a:rPr>
-              <a:t>17.6%</a:t>
+              <a:t>20.9%</a:t>
             </a:r>
             <a:endParaRPr lang="en-US" sz="2600" dirty="0"/>
           </a:p>
@@ -12504,7 +13647,7 @@
                 <a:ea typeface="Cambria" pitchFamily="34" charset="-122"/>
                 <a:cs typeface="Cambria" pitchFamily="34" charset="-120"/>
               </a:rPr>
-              <a:t>4.7%</a:t>
+              <a:t>3.8%</a:t>
             </a:r>
             <a:endParaRPr lang="en-US" sz="2600" dirty="0"/>
           </a:p>
@@ -12651,7 +13794,7 @@
                 <a:ea typeface="Cambria" pitchFamily="34" charset="-122"/>
                 <a:cs typeface="Cambria" pitchFamily="34" charset="-120"/>
               </a:rPr>
-              <a:t>20.14×</a:t>
+              <a:t>27.21×</a:t>
             </a:r>
             <a:endParaRPr lang="en-US" sz="2600" dirty="0"/>
           </a:p>
@@ -12732,7 +13875,7 @@
                 <a:ea typeface="Calibri" pitchFamily="34" charset="-122"/>
                 <a:cs typeface="Calibri" pitchFamily="34" charset="-120"/>
               </a:rPr>
-              <a:t>real cores 22.4% vs shuffled-sequence null 1.1%</a:t>
+              <a:t>real cores 24.8% vs shuffled-sequence null 0.9%</a:t>
             </a:r>
             <a:endParaRPr lang="en-US" sz="950" dirty="0"/>
           </a:p>
@@ -12792,7 +13935,7 @@
                 <a:ea typeface="Calibri" pitchFamily="34" charset="-122"/>
                 <a:cs typeface="Calibri" pitchFamily="34" charset="-120"/>
               </a:rPr>
-              <a:t>Re-running the identical screen on cores drawn from shuffled versions of the same sequences — same composition, no real self-similarity — gives 1.1% at the 8/9 cut against 22.4% for real cores. A 5-of-9 "TCR-face" screen, the obvious shortcut, was tried first and discarded: with only five positions specified it matches the human proteome by chance several times per query and flags nearly everything.</a:t>
+              <a:t>Re-running the identical screen on cores drawn from shuffled versions of the same sequences — same composition, no real self-similarity — gives 0.9% at the 8/9 cut against 24.8% for real cores. A 5-of-9 "TCR-face" screen, the obvious shortcut, was tried first and discarded: with only five positions specified it matches the human proteome by chance several times per query and flags nearly everything.</a:t>
             </a:r>
             <a:endParaRPr lang="en-US" sz="1300" dirty="0"/>
           </a:p>
@@ -12974,6 +14117,1785 @@
                 <a:ea typeface="Calibri" pitchFamily="34" charset="-122"/>
                 <a:cs typeface="Calibri" pitchFamily="34" charset="-120"/>
               </a:rPr>
+              <a:t>MODULE 4 · BOUNDARY CONTROLS</a:t>
+            </a:r>
+            <a:endParaRPr lang="en-US" sz="1050" dirty="0"/>
+          </a:p>
+        </p:txBody>
+      </p:sp>
+      <p:sp>
+        <p:nvSpPr>
+          <p:cNvPr id="3" name="Text 1"/>
+          <p:cNvSpPr/>
+          <p:nvPr/>
+        </p:nvSpPr>
+        <p:spPr>
+          <a:xfrm>
+            <a:off x="566928" y="548640"/>
+            <a:ext cx="11027664" cy="548640"/>
+          </a:xfrm>
+          <a:prstGeom prst="rect">
+            <a:avLst/>
+          </a:prstGeom>
+          <a:noFill/>
+          <a:ln/>
+        </p:spPr>
+        <p:txBody>
+          <a:bodyPr wrap="square" lIns="0" tIns="0" rIns="0" bIns="0" rtlCol="0" anchor="ctr"/>
+          <a:lstStyle/>
+          <a:p>
+            <a:pPr indent="0" marL="0">
+              <a:buNone/>
+            </a:pPr>
+            <a:r>
+              <a:rPr lang="en-US" sz="2700" b="1" dirty="0">
+                <a:solidFill>
+                  <a:srgbClr val="12212E"/>
+                </a:solidFill>
+                <a:latin typeface="Cambria" pitchFamily="34" charset="0"/>
+                <a:ea typeface="Cambria" pitchFamily="34" charset="-122"/>
+                <a:cs typeface="Cambria" pitchFamily="34" charset="-120"/>
+              </a:rPr>
+              <a:t>Where the filter is wrong, measured</a:t>
+            </a:r>
+            <a:endParaRPr lang="en-US" sz="2700" dirty="0"/>
+          </a:p>
+        </p:txBody>
+      </p:sp>
+      <p:sp>
+        <p:nvSpPr>
+          <p:cNvPr id="4" name="Text 2"/>
+          <p:cNvSpPr/>
+          <p:nvPr/>
+        </p:nvSpPr>
+        <p:spPr>
+          <a:xfrm>
+            <a:off x="566928" y="1170432"/>
+            <a:ext cx="11027664" cy="457200"/>
+          </a:xfrm>
+          <a:prstGeom prst="rect">
+            <a:avLst/>
+          </a:prstGeom>
+          <a:noFill/>
+          <a:ln/>
+        </p:spPr>
+        <p:txBody>
+          <a:bodyPr wrap="square" lIns="0" tIns="0" rIns="0" bIns="0" rtlCol="0" anchor="ctr"/>
+          <a:lstStyle/>
+          <a:p>
+            <a:pPr indent="0" marL="0">
+              <a:lnSpc>
+                <a:spcPts val="1600"/>
+              </a:lnSpc>
+              <a:buNone/>
+            </a:pPr>
+            <a:r>
+              <a:rPr lang="en-US" sz="1200" dirty="0">
+                <a:solidFill>
+                  <a:srgbClr val="12212E"/>
+                </a:solidFill>
+                <a:latin typeface="Calibri" pitchFamily="34" charset="0"/>
+                <a:ea typeface="Calibri" pitchFamily="34" charset="-122"/>
+                <a:cs typeface="Calibri" pitchFamily="34" charset="-120"/>
+              </a:rPr>
+              <a:t>The filter's rule is “self implies tolerated”. That is right often enough to be worth applying and wrong often enough to be worth measuring, so the batch carries two controls that sit on the boundary.</a:t>
+            </a:r>
+            <a:endParaRPr lang="en-US" sz="1200" dirty="0"/>
+          </a:p>
+        </p:txBody>
+      </p:sp>
+      <p:graphicFrame>
+        <p:nvGraphicFramePr>
+          <p:cNvPr id="8" name="Table 0"/>
+          <p:cNvGraphicFramePr>
+            <a:graphicFrameLocks noGrp="1"/>
+          </p:cNvGraphicFramePr>
+          <p:nvPr>
+            <p:extLst>
+              <p:ext uri="{D42A27DB-BD31-4B8C-83A1-F6EECF244321}">
+                <p14:modId xmlns:p14="http://schemas.microsoft.com/office/powerpoint/2010/main" val="1579011935"/>
+              </p:ext>
+            </p:extLst>
+          </p:nvPr>
+        </p:nvGraphicFramePr>
+        <p:xfrm>
+          <a:off x="566928" y="1783080"/>
+          <a:ext cx="11027664" cy="914400"/>
+        </p:xfrm>
+        <a:graphic>
+          <a:graphicData uri="http://schemas.openxmlformats.org/drawingml/2006/table">
+            <a:tbl>
+              <a:tblPr/>
+              <a:tblGrid>
+                <a:gridCol w="2286000"/>
+                <a:gridCol w="2011680"/>
+                <a:gridCol w="1371600"/>
+                <a:gridCol w="914400"/>
+                <a:gridCol w="1463040"/>
+                <a:gridCol w="1463040"/>
+                <a:gridCol w="1517904"/>
+              </a:tblGrid>
+              <a:tr h="347472">
+                <a:tc>
+                  <a:txBody>
+                    <a:bodyPr/>
+                    <a:lstStyle/>
+                    <a:p>
+                      <a:pPr indent="0" marL="0">
+                        <a:buNone/>
+                      </a:pPr>
+                      <a:r>
+                        <a:rPr lang="en-US" sz="850" b="1" spc="60" kern="0" dirty="0">
+                          <a:solidFill>
+                            <a:srgbClr val="63748A"/>
+                          </a:solidFill>
+                          <a:latin typeface="Calibri" pitchFamily="34" charset="0"/>
+                          <a:ea typeface="Calibri" pitchFamily="34" charset="-122"/>
+                          <a:cs typeface="Calibri" pitchFamily="34" charset="-120"/>
+                        </a:rPr>
+                        <a:t>Control</a:t>
+                      </a:r>
+                      <a:endParaRPr lang="en-US" sz="850" dirty="0">
+                        <a:latin typeface="Calibri" charset="0"/>
+                        <a:ea typeface="Calibri" charset="0"/>
+                        <a:cs typeface="Calibri" charset="0"/>
+                      </a:endParaRPr>
+                    </a:p>
+                  </a:txBody>
+                  <a:tcPr marL="91440" marR="91440" marT="45720" marB="45720" anchor="ctr">
+                    <a:lnL w="6350" cap="flat" cmpd="sng" algn="ctr">
+                      <a:solidFill>
+                        <a:srgbClr val="DCE4EC"/>
+                      </a:solidFill>
+                      <a:prstDash val="solid"/>
+                      <a:round/>
+                      <a:headEnd type="none" w="med" len="med"/>
+                      <a:tailEnd type="none" w="med" len="med"/>
+                    </a:lnL>
+                    <a:lnR w="6350" cap="flat" cmpd="sng" algn="ctr">
+                      <a:solidFill>
+                        <a:srgbClr val="DCE4EC"/>
+                      </a:solidFill>
+                      <a:prstDash val="solid"/>
+                      <a:round/>
+                      <a:headEnd type="none" w="med" len="med"/>
+                      <a:tailEnd type="none" w="med" len="med"/>
+                    </a:lnR>
+                    <a:lnT w="6350" cap="flat" cmpd="sng" algn="ctr">
+                      <a:solidFill>
+                        <a:srgbClr val="DCE4EC"/>
+                      </a:solidFill>
+                      <a:prstDash val="solid"/>
+                      <a:round/>
+                      <a:headEnd type="none" w="med" len="med"/>
+                      <a:tailEnd type="none" w="med" len="med"/>
+                    </a:lnT>
+                    <a:lnB w="6350" cap="flat" cmpd="sng" algn="ctr">
+                      <a:solidFill>
+                        <a:srgbClr val="DCE4EC"/>
+                      </a:solidFill>
+                      <a:prstDash val="solid"/>
+                      <a:round/>
+                      <a:headEnd type="none" w="med" len="med"/>
+                      <a:tailEnd type="none" w="med" len="med"/>
+                    </a:lnB>
+                    <a:solidFill>
+                      <a:srgbClr val="F2F6F9"/>
+                    </a:solidFill>
+                  </a:tcPr>
+                </a:tc>
+                <a:tc>
+                  <a:txBody>
+                    <a:bodyPr/>
+                    <a:lstStyle/>
+                    <a:p>
+                      <a:pPr indent="0" marL="0">
+                        <a:buNone/>
+                      </a:pPr>
+                      <a:r>
+                        <a:rPr lang="en-US" sz="850" b="1" spc="60" kern="0" dirty="0">
+                          <a:solidFill>
+                            <a:srgbClr val="63748A"/>
+                          </a:solidFill>
+                          <a:latin typeface="Calibri" pitchFamily="34" charset="0"/>
+                          <a:ea typeface="Calibri" pitchFamily="34" charset="-122"/>
+                          <a:cs typeface="Calibri" pitchFamily="34" charset="-120"/>
+                        </a:rPr>
+                        <a:t>Role</a:t>
+                      </a:r>
+                      <a:endParaRPr lang="en-US" sz="850" dirty="0">
+                        <a:latin typeface="Calibri" charset="0"/>
+                        <a:ea typeface="Calibri" charset="0"/>
+                        <a:cs typeface="Calibri" charset="0"/>
+                      </a:endParaRPr>
+                    </a:p>
+                  </a:txBody>
+                  <a:tcPr marL="91440" marR="91440" marT="45720" marB="45720" anchor="ctr">
+                    <a:lnL w="6350" cap="flat" cmpd="sng" algn="ctr">
+                      <a:solidFill>
+                        <a:srgbClr val="DCE4EC"/>
+                      </a:solidFill>
+                      <a:prstDash val="solid"/>
+                      <a:round/>
+                      <a:headEnd type="none" w="med" len="med"/>
+                      <a:tailEnd type="none" w="med" len="med"/>
+                    </a:lnL>
+                    <a:lnR w="6350" cap="flat" cmpd="sng" algn="ctr">
+                      <a:solidFill>
+                        <a:srgbClr val="DCE4EC"/>
+                      </a:solidFill>
+                      <a:prstDash val="solid"/>
+                      <a:round/>
+                      <a:headEnd type="none" w="med" len="med"/>
+                      <a:tailEnd type="none" w="med" len="med"/>
+                    </a:lnR>
+                    <a:lnT w="6350" cap="flat" cmpd="sng" algn="ctr">
+                      <a:solidFill>
+                        <a:srgbClr val="DCE4EC"/>
+                      </a:solidFill>
+                      <a:prstDash val="solid"/>
+                      <a:round/>
+                      <a:headEnd type="none" w="med" len="med"/>
+                      <a:tailEnd type="none" w="med" len="med"/>
+                    </a:lnT>
+                    <a:lnB w="6350" cap="flat" cmpd="sng" algn="ctr">
+                      <a:solidFill>
+                        <a:srgbClr val="DCE4EC"/>
+                      </a:solidFill>
+                      <a:prstDash val="solid"/>
+                      <a:round/>
+                      <a:headEnd type="none" w="med" len="med"/>
+                      <a:tailEnd type="none" w="med" len="med"/>
+                    </a:lnB>
+                    <a:solidFill>
+                      <a:srgbClr val="F2F6F9"/>
+                    </a:solidFill>
+                  </a:tcPr>
+                </a:tc>
+                <a:tc>
+                  <a:txBody>
+                    <a:bodyPr/>
+                    <a:lstStyle/>
+                    <a:p>
+                      <a:pPr indent="0" marL="0">
+                        <a:buNone/>
+                      </a:pPr>
+                      <a:r>
+                        <a:rPr lang="en-US" sz="850" b="1" spc="60" kern="0" dirty="0">
+                          <a:solidFill>
+                            <a:srgbClr val="63748A"/>
+                          </a:solidFill>
+                          <a:latin typeface="Calibri" pitchFamily="34" charset="0"/>
+                          <a:ea typeface="Calibri" pitchFamily="34" charset="-122"/>
+                          <a:cs typeface="Calibri" pitchFamily="34" charset="-120"/>
+                        </a:rPr>
+                        <a:t>DR at %Rank&lt;1</a:t>
+                      </a:r>
+                      <a:endParaRPr lang="en-US" sz="850" dirty="0">
+                        <a:latin typeface="Calibri" charset="0"/>
+                        <a:ea typeface="Calibri" charset="0"/>
+                        <a:cs typeface="Calibri" charset="0"/>
+                      </a:endParaRPr>
+                    </a:p>
+                  </a:txBody>
+                  <a:tcPr marL="91440" marR="91440" marT="45720" marB="45720" anchor="ctr">
+                    <a:lnL w="6350" cap="flat" cmpd="sng" algn="ctr">
+                      <a:solidFill>
+                        <a:srgbClr val="DCE4EC"/>
+                      </a:solidFill>
+                      <a:prstDash val="solid"/>
+                      <a:round/>
+                      <a:headEnd type="none" w="med" len="med"/>
+                      <a:tailEnd type="none" w="med" len="med"/>
+                    </a:lnL>
+                    <a:lnR w="6350" cap="flat" cmpd="sng" algn="ctr">
+                      <a:solidFill>
+                        <a:srgbClr val="DCE4EC"/>
+                      </a:solidFill>
+                      <a:prstDash val="solid"/>
+                      <a:round/>
+                      <a:headEnd type="none" w="med" len="med"/>
+                      <a:tailEnd type="none" w="med" len="med"/>
+                    </a:lnR>
+                    <a:lnT w="6350" cap="flat" cmpd="sng" algn="ctr">
+                      <a:solidFill>
+                        <a:srgbClr val="DCE4EC"/>
+                      </a:solidFill>
+                      <a:prstDash val="solid"/>
+                      <a:round/>
+                      <a:headEnd type="none" w="med" len="med"/>
+                      <a:tailEnd type="none" w="med" len="med"/>
+                    </a:lnT>
+                    <a:lnB w="6350" cap="flat" cmpd="sng" algn="ctr">
+                      <a:solidFill>
+                        <a:srgbClr val="DCE4EC"/>
+                      </a:solidFill>
+                      <a:prstDash val="solid"/>
+                      <a:round/>
+                      <a:headEnd type="none" w="med" len="med"/>
+                      <a:tailEnd type="none" w="med" len="med"/>
+                    </a:lnB>
+                    <a:solidFill>
+                      <a:srgbClr val="F2F6F9"/>
+                    </a:solidFill>
+                  </a:tcPr>
+                </a:tc>
+                <a:tc>
+                  <a:txBody>
+                    <a:bodyPr/>
+                    <a:lstStyle/>
+                    <a:p>
+                      <a:pPr indent="0" marL="0">
+                        <a:buNone/>
+                      </a:pPr>
+                      <a:r>
+                        <a:rPr lang="en-US" sz="850" b="1" spc="60" kern="0" dirty="0">
+                          <a:solidFill>
+                            <a:srgbClr val="63748A"/>
+                          </a:solidFill>
+                          <a:latin typeface="Calibri" pitchFamily="34" charset="0"/>
+                          <a:ea typeface="Calibri" pitchFamily="34" charset="-122"/>
+                          <a:cs typeface="Calibri" pitchFamily="34" charset="-120"/>
+                        </a:rPr>
+                        <a:t>at &lt;5</a:t>
+                      </a:r>
+                      <a:endParaRPr lang="en-US" sz="850" dirty="0">
+                        <a:latin typeface="Calibri" charset="0"/>
+                        <a:ea typeface="Calibri" charset="0"/>
+                        <a:cs typeface="Calibri" charset="0"/>
+                      </a:endParaRPr>
+                    </a:p>
+                  </a:txBody>
+                  <a:tcPr marL="91440" marR="91440" marT="45720" marB="45720" anchor="ctr">
+                    <a:lnL w="6350" cap="flat" cmpd="sng" algn="ctr">
+                      <a:solidFill>
+                        <a:srgbClr val="DCE4EC"/>
+                      </a:solidFill>
+                      <a:prstDash val="solid"/>
+                      <a:round/>
+                      <a:headEnd type="none" w="med" len="med"/>
+                      <a:tailEnd type="none" w="med" len="med"/>
+                    </a:lnL>
+                    <a:lnR w="6350" cap="flat" cmpd="sng" algn="ctr">
+                      <a:solidFill>
+                        <a:srgbClr val="DCE4EC"/>
+                      </a:solidFill>
+                      <a:prstDash val="solid"/>
+                      <a:round/>
+                      <a:headEnd type="none" w="med" len="med"/>
+                      <a:tailEnd type="none" w="med" len="med"/>
+                    </a:lnR>
+                    <a:lnT w="6350" cap="flat" cmpd="sng" algn="ctr">
+                      <a:solidFill>
+                        <a:srgbClr val="DCE4EC"/>
+                      </a:solidFill>
+                      <a:prstDash val="solid"/>
+                      <a:round/>
+                      <a:headEnd type="none" w="med" len="med"/>
+                      <a:tailEnd type="none" w="med" len="med"/>
+                    </a:lnT>
+                    <a:lnB w="6350" cap="flat" cmpd="sng" algn="ctr">
+                      <a:solidFill>
+                        <a:srgbClr val="DCE4EC"/>
+                      </a:solidFill>
+                      <a:prstDash val="solid"/>
+                      <a:round/>
+                      <a:headEnd type="none" w="med" len="med"/>
+                      <a:tailEnd type="none" w="med" len="med"/>
+                    </a:lnB>
+                    <a:solidFill>
+                      <a:srgbClr val="F2F6F9"/>
+                    </a:solidFill>
+                  </a:tcPr>
+                </a:tc>
+                <a:tc>
+                  <a:txBody>
+                    <a:bodyPr/>
+                    <a:lstStyle/>
+                    <a:p>
+                      <a:pPr indent="0" marL="0">
+                        <a:buNone/>
+                      </a:pPr>
+                      <a:r>
+                        <a:rPr lang="en-US" sz="850" b="1" spc="60" kern="0" dirty="0">
+                          <a:solidFill>
+                            <a:srgbClr val="63748A"/>
+                          </a:solidFill>
+                          <a:latin typeface="Calibri" pitchFamily="34" charset="0"/>
+                          <a:ea typeface="Calibri" pitchFamily="34" charset="-122"/>
+                          <a:cs typeface="Calibri" pitchFamily="34" charset="-120"/>
+                        </a:rPr>
+                        <a:t>Cores tolerised</a:t>
+                      </a:r>
+                      <a:endParaRPr lang="en-US" sz="850" dirty="0">
+                        <a:latin typeface="Calibri" charset="0"/>
+                        <a:ea typeface="Calibri" charset="0"/>
+                        <a:cs typeface="Calibri" charset="0"/>
+                      </a:endParaRPr>
+                    </a:p>
+                  </a:txBody>
+                  <a:tcPr marL="91440" marR="91440" marT="45720" marB="45720" anchor="ctr">
+                    <a:lnL w="6350" cap="flat" cmpd="sng" algn="ctr">
+                      <a:solidFill>
+                        <a:srgbClr val="DCE4EC"/>
+                      </a:solidFill>
+                      <a:prstDash val="solid"/>
+                      <a:round/>
+                      <a:headEnd type="none" w="med" len="med"/>
+                      <a:tailEnd type="none" w="med" len="med"/>
+                    </a:lnL>
+                    <a:lnR w="6350" cap="flat" cmpd="sng" algn="ctr">
+                      <a:solidFill>
+                        <a:srgbClr val="DCE4EC"/>
+                      </a:solidFill>
+                      <a:prstDash val="solid"/>
+                      <a:round/>
+                      <a:headEnd type="none" w="med" len="med"/>
+                      <a:tailEnd type="none" w="med" len="med"/>
+                    </a:lnR>
+                    <a:lnT w="6350" cap="flat" cmpd="sng" algn="ctr">
+                      <a:solidFill>
+                        <a:srgbClr val="DCE4EC"/>
+                      </a:solidFill>
+                      <a:prstDash val="solid"/>
+                      <a:round/>
+                      <a:headEnd type="none" w="med" len="med"/>
+                      <a:tailEnd type="none" w="med" len="med"/>
+                    </a:lnT>
+                    <a:lnB w="6350" cap="flat" cmpd="sng" algn="ctr">
+                      <a:solidFill>
+                        <a:srgbClr val="DCE4EC"/>
+                      </a:solidFill>
+                      <a:prstDash val="solid"/>
+                      <a:round/>
+                      <a:headEnd type="none" w="med" len="med"/>
+                      <a:tailEnd type="none" w="med" len="med"/>
+                    </a:lnB>
+                    <a:solidFill>
+                      <a:srgbClr val="F2F6F9"/>
+                    </a:solidFill>
+                  </a:tcPr>
+                </a:tc>
+                <a:tc>
+                  <a:txBody>
+                    <a:bodyPr/>
+                    <a:lstStyle/>
+                    <a:p>
+                      <a:pPr indent="0" marL="0">
+                        <a:buNone/>
+                      </a:pPr>
+                      <a:r>
+                        <a:rPr lang="en-US" sz="850" b="1" spc="60" kern="0" dirty="0">
+                          <a:solidFill>
+                            <a:srgbClr val="63748A"/>
+                          </a:solidFill>
+                          <a:latin typeface="Calibri" pitchFamily="34" charset="0"/>
+                          <a:ea typeface="Calibri" pitchFamily="34" charset="-122"/>
+                          <a:cs typeface="Calibri" pitchFamily="34" charset="-120"/>
+                        </a:rPr>
+                        <a:t>pIRS unfiltered</a:t>
+                      </a:r>
+                      <a:endParaRPr lang="en-US" sz="850" dirty="0">
+                        <a:latin typeface="Calibri" charset="0"/>
+                        <a:ea typeface="Calibri" charset="0"/>
+                        <a:cs typeface="Calibri" charset="0"/>
+                      </a:endParaRPr>
+                    </a:p>
+                  </a:txBody>
+                  <a:tcPr marL="91440" marR="91440" marT="45720" marB="45720" anchor="ctr">
+                    <a:lnL w="6350" cap="flat" cmpd="sng" algn="ctr">
+                      <a:solidFill>
+                        <a:srgbClr val="DCE4EC"/>
+                      </a:solidFill>
+                      <a:prstDash val="solid"/>
+                      <a:round/>
+                      <a:headEnd type="none" w="med" len="med"/>
+                      <a:tailEnd type="none" w="med" len="med"/>
+                    </a:lnL>
+                    <a:lnR w="6350" cap="flat" cmpd="sng" algn="ctr">
+                      <a:solidFill>
+                        <a:srgbClr val="DCE4EC"/>
+                      </a:solidFill>
+                      <a:prstDash val="solid"/>
+                      <a:round/>
+                      <a:headEnd type="none" w="med" len="med"/>
+                      <a:tailEnd type="none" w="med" len="med"/>
+                    </a:lnR>
+                    <a:lnT w="6350" cap="flat" cmpd="sng" algn="ctr">
+                      <a:solidFill>
+                        <a:srgbClr val="DCE4EC"/>
+                      </a:solidFill>
+                      <a:prstDash val="solid"/>
+                      <a:round/>
+                      <a:headEnd type="none" w="med" len="med"/>
+                      <a:tailEnd type="none" w="med" len="med"/>
+                    </a:lnT>
+                    <a:lnB w="6350" cap="flat" cmpd="sng" algn="ctr">
+                      <a:solidFill>
+                        <a:srgbClr val="DCE4EC"/>
+                      </a:solidFill>
+                      <a:prstDash val="solid"/>
+                      <a:round/>
+                      <a:headEnd type="none" w="med" len="med"/>
+                      <a:tailEnd type="none" w="med" len="med"/>
+                    </a:lnB>
+                    <a:solidFill>
+                      <a:srgbClr val="F2F6F9"/>
+                    </a:solidFill>
+                  </a:tcPr>
+                </a:tc>
+                <a:tc>
+                  <a:txBody>
+                    <a:bodyPr/>
+                    <a:lstStyle/>
+                    <a:p>
+                      <a:pPr indent="0" marL="0">
+                        <a:buNone/>
+                      </a:pPr>
+                      <a:r>
+                        <a:rPr lang="en-US" sz="850" b="1" spc="60" kern="0" dirty="0">
+                          <a:solidFill>
+                            <a:srgbClr val="63748A"/>
+                          </a:solidFill>
+                          <a:latin typeface="Calibri" pitchFamily="34" charset="0"/>
+                          <a:ea typeface="Calibri" pitchFamily="34" charset="-122"/>
+                          <a:cs typeface="Calibri" pitchFamily="34" charset="-120"/>
+                        </a:rPr>
+                        <a:t>pIRS filtered</a:t>
+                      </a:r>
+                      <a:endParaRPr lang="en-US" sz="850" dirty="0">
+                        <a:latin typeface="Calibri" charset="0"/>
+                        <a:ea typeface="Calibri" charset="0"/>
+                        <a:cs typeface="Calibri" charset="0"/>
+                      </a:endParaRPr>
+                    </a:p>
+                  </a:txBody>
+                  <a:tcPr marL="91440" marR="91440" marT="45720" marB="45720" anchor="ctr">
+                    <a:lnL w="6350" cap="flat" cmpd="sng" algn="ctr">
+                      <a:solidFill>
+                        <a:srgbClr val="DCE4EC"/>
+                      </a:solidFill>
+                      <a:prstDash val="solid"/>
+                      <a:round/>
+                      <a:headEnd type="none" w="med" len="med"/>
+                      <a:tailEnd type="none" w="med" len="med"/>
+                    </a:lnL>
+                    <a:lnR w="6350" cap="flat" cmpd="sng" algn="ctr">
+                      <a:solidFill>
+                        <a:srgbClr val="DCE4EC"/>
+                      </a:solidFill>
+                      <a:prstDash val="solid"/>
+                      <a:round/>
+                      <a:headEnd type="none" w="med" len="med"/>
+                      <a:tailEnd type="none" w="med" len="med"/>
+                    </a:lnR>
+                    <a:lnT w="6350" cap="flat" cmpd="sng" algn="ctr">
+                      <a:solidFill>
+                        <a:srgbClr val="DCE4EC"/>
+                      </a:solidFill>
+                      <a:prstDash val="solid"/>
+                      <a:round/>
+                      <a:headEnd type="none" w="med" len="med"/>
+                      <a:tailEnd type="none" w="med" len="med"/>
+                    </a:lnT>
+                    <a:lnB w="6350" cap="flat" cmpd="sng" algn="ctr">
+                      <a:solidFill>
+                        <a:srgbClr val="DCE4EC"/>
+                      </a:solidFill>
+                      <a:prstDash val="solid"/>
+                      <a:round/>
+                      <a:headEnd type="none" w="med" len="med"/>
+                      <a:tailEnd type="none" w="med" len="med"/>
+                    </a:lnB>
+                    <a:solidFill>
+                      <a:srgbClr val="F2F6F9"/>
+                    </a:solidFill>
+                  </a:tcPr>
+                </a:tc>
+              </a:tr>
+              <a:tr h="347472">
+                <a:tc>
+                  <a:txBody>
+                    <a:bodyPr/>
+                    <a:lstStyle/>
+                    <a:p>
+                      <a:pPr indent="0" marL="0">
+                        <a:buNone/>
+                      </a:pPr>
+                      <a:r>
+                        <a:rPr lang="en-US" sz="900" b="1" dirty="0">
+                          <a:solidFill>
+                            <a:srgbClr val="12212E"/>
+                          </a:solidFill>
+                          <a:latin typeface="Courier New" pitchFamily="34" charset="0"/>
+                          <a:ea typeface="Courier New" pitchFamily="34" charset="-122"/>
+                          <a:cs typeface="Courier New" pitchFamily="34" charset="-120"/>
+                        </a:rPr>
+                        <a:t>MBP_85_99</a:t>
+                      </a:r>
+                      <a:endParaRPr lang="en-US" sz="900" dirty="0">
+                        <a:latin typeface="Courier New" charset="0"/>
+                        <a:ea typeface="Courier New" charset="0"/>
+                        <a:cs typeface="Courier New" charset="0"/>
+                      </a:endParaRPr>
+                    </a:p>
+                  </a:txBody>
+                  <a:tcPr marL="91440" marR="91440" marT="45720" marB="45720" anchor="ctr">
+                    <a:lnL w="6350" cap="flat" cmpd="sng" algn="ctr">
+                      <a:solidFill>
+                        <a:srgbClr val="DCE4EC"/>
+                      </a:solidFill>
+                      <a:prstDash val="solid"/>
+                      <a:round/>
+                      <a:headEnd type="none" w="med" len="med"/>
+                      <a:tailEnd type="none" w="med" len="med"/>
+                    </a:lnL>
+                    <a:lnR w="6350" cap="flat" cmpd="sng" algn="ctr">
+                      <a:solidFill>
+                        <a:srgbClr val="DCE4EC"/>
+                      </a:solidFill>
+                      <a:prstDash val="solid"/>
+                      <a:round/>
+                      <a:headEnd type="none" w="med" len="med"/>
+                      <a:tailEnd type="none" w="med" len="med"/>
+                    </a:lnR>
+                    <a:lnT w="6350" cap="flat" cmpd="sng" algn="ctr">
+                      <a:solidFill>
+                        <a:srgbClr val="DCE4EC"/>
+                      </a:solidFill>
+                      <a:prstDash val="solid"/>
+                      <a:round/>
+                      <a:headEnd type="none" w="med" len="med"/>
+                      <a:tailEnd type="none" w="med" len="med"/>
+                    </a:lnT>
+                    <a:lnB w="6350" cap="flat" cmpd="sng" algn="ctr">
+                      <a:solidFill>
+                        <a:srgbClr val="DCE4EC"/>
+                      </a:solidFill>
+                      <a:prstDash val="solid"/>
+                      <a:round/>
+                      <a:headEnd type="none" w="med" len="med"/>
+                      <a:tailEnd type="none" w="med" len="med"/>
+                    </a:lnB>
+                  </a:tcPr>
+                </a:tc>
+                <a:tc>
+                  <a:txBody>
+                    <a:bodyPr/>
+                    <a:lstStyle/>
+                    <a:p>
+                      <a:pPr indent="0" marL="0">
+                        <a:buNone/>
+                      </a:pPr>
+                      <a:r>
+                        <a:rPr lang="en-US" sz="900" dirty="0">
+                          <a:solidFill>
+                            <a:srgbClr val="C9752B"/>
+                          </a:solidFill>
+                          <a:latin typeface="Calibri" pitchFamily="34" charset="0"/>
+                          <a:ea typeface="Calibri" pitchFamily="34" charset="-122"/>
+                          <a:cs typeface="Calibri" pitchFamily="34" charset="-120"/>
+                        </a:rPr>
+                        <a:t>self immunogenic control</a:t>
+                      </a:r>
+                      <a:endParaRPr lang="en-US" sz="900" dirty="0">
+                        <a:latin typeface="Calibri" charset="0"/>
+                        <a:ea typeface="Calibri" charset="0"/>
+                        <a:cs typeface="Calibri" charset="0"/>
+                      </a:endParaRPr>
+                    </a:p>
+                  </a:txBody>
+                  <a:tcPr marL="91440" marR="91440" marT="45720" marB="45720" anchor="ctr">
+                    <a:lnL w="6350" cap="flat" cmpd="sng" algn="ctr">
+                      <a:solidFill>
+                        <a:srgbClr val="DCE4EC"/>
+                      </a:solidFill>
+                      <a:prstDash val="solid"/>
+                      <a:round/>
+                      <a:headEnd type="none" w="med" len="med"/>
+                      <a:tailEnd type="none" w="med" len="med"/>
+                    </a:lnL>
+                    <a:lnR w="6350" cap="flat" cmpd="sng" algn="ctr">
+                      <a:solidFill>
+                        <a:srgbClr val="DCE4EC"/>
+                      </a:solidFill>
+                      <a:prstDash val="solid"/>
+                      <a:round/>
+                      <a:headEnd type="none" w="med" len="med"/>
+                      <a:tailEnd type="none" w="med" len="med"/>
+                    </a:lnR>
+                    <a:lnT w="6350" cap="flat" cmpd="sng" algn="ctr">
+                      <a:solidFill>
+                        <a:srgbClr val="DCE4EC"/>
+                      </a:solidFill>
+                      <a:prstDash val="solid"/>
+                      <a:round/>
+                      <a:headEnd type="none" w="med" len="med"/>
+                      <a:tailEnd type="none" w="med" len="med"/>
+                    </a:lnT>
+                    <a:lnB w="6350" cap="flat" cmpd="sng" algn="ctr">
+                      <a:solidFill>
+                        <a:srgbClr val="DCE4EC"/>
+                      </a:solidFill>
+                      <a:prstDash val="solid"/>
+                      <a:round/>
+                      <a:headEnd type="none" w="med" len="med"/>
+                      <a:tailEnd type="none" w="med" len="med"/>
+                    </a:lnB>
+                  </a:tcPr>
+                </a:tc>
+                <a:tc>
+                  <a:txBody>
+                    <a:bodyPr/>
+                    <a:lstStyle/>
+                    <a:p>
+                      <a:pPr algn="r" indent="0" marL="0">
+                        <a:buNone/>
+                      </a:pPr>
+                      <a:r>
+                        <a:rPr lang="en-US" sz="1000" dirty="0">
+                          <a:solidFill>
+                            <a:srgbClr val="12212E"/>
+                          </a:solidFill>
+                          <a:latin typeface="Calibri" pitchFamily="34" charset="0"/>
+                          <a:ea typeface="Calibri" pitchFamily="34" charset="-122"/>
+                          <a:cs typeface="Calibri" pitchFamily="34" charset="-120"/>
+                        </a:rPr>
+                        <a:t>10/25</a:t>
+                      </a:r>
+                      <a:endParaRPr lang="en-US" sz="1000" dirty="0">
+                        <a:latin typeface="Calibri" charset="0"/>
+                        <a:ea typeface="Calibri" charset="0"/>
+                        <a:cs typeface="Calibri" charset="0"/>
+                      </a:endParaRPr>
+                    </a:p>
+                  </a:txBody>
+                  <a:tcPr marL="91440" marR="91440" marT="45720" marB="45720" anchor="ctr">
+                    <a:lnL w="6350" cap="flat" cmpd="sng" algn="ctr">
+                      <a:solidFill>
+                        <a:srgbClr val="DCE4EC"/>
+                      </a:solidFill>
+                      <a:prstDash val="solid"/>
+                      <a:round/>
+                      <a:headEnd type="none" w="med" len="med"/>
+                      <a:tailEnd type="none" w="med" len="med"/>
+                    </a:lnL>
+                    <a:lnR w="6350" cap="flat" cmpd="sng" algn="ctr">
+                      <a:solidFill>
+                        <a:srgbClr val="DCE4EC"/>
+                      </a:solidFill>
+                      <a:prstDash val="solid"/>
+                      <a:round/>
+                      <a:headEnd type="none" w="med" len="med"/>
+                      <a:tailEnd type="none" w="med" len="med"/>
+                    </a:lnR>
+                    <a:lnT w="6350" cap="flat" cmpd="sng" algn="ctr">
+                      <a:solidFill>
+                        <a:srgbClr val="DCE4EC"/>
+                      </a:solidFill>
+                      <a:prstDash val="solid"/>
+                      <a:round/>
+                      <a:headEnd type="none" w="med" len="med"/>
+                      <a:tailEnd type="none" w="med" len="med"/>
+                    </a:lnT>
+                    <a:lnB w="6350" cap="flat" cmpd="sng" algn="ctr">
+                      <a:solidFill>
+                        <a:srgbClr val="DCE4EC"/>
+                      </a:solidFill>
+                      <a:prstDash val="solid"/>
+                      <a:round/>
+                      <a:headEnd type="none" w="med" len="med"/>
+                      <a:tailEnd type="none" w="med" len="med"/>
+                    </a:lnB>
+                  </a:tcPr>
+                </a:tc>
+                <a:tc>
+                  <a:txBody>
+                    <a:bodyPr/>
+                    <a:lstStyle/>
+                    <a:p>
+                      <a:pPr algn="r" indent="0" marL="0">
+                        <a:buNone/>
+                      </a:pPr>
+                      <a:r>
+                        <a:rPr lang="en-US" sz="1000" dirty="0">
+                          <a:solidFill>
+                            <a:srgbClr val="12212E"/>
+                          </a:solidFill>
+                          <a:latin typeface="Calibri" pitchFamily="34" charset="0"/>
+                          <a:ea typeface="Calibri" pitchFamily="34" charset="-122"/>
+                          <a:cs typeface="Calibri" pitchFamily="34" charset="-120"/>
+                        </a:rPr>
+                        <a:t>20/25</a:t>
+                      </a:r>
+                      <a:endParaRPr lang="en-US" sz="1000" dirty="0">
+                        <a:latin typeface="Calibri" charset="0"/>
+                        <a:ea typeface="Calibri" charset="0"/>
+                        <a:cs typeface="Calibri" charset="0"/>
+                      </a:endParaRPr>
+                    </a:p>
+                  </a:txBody>
+                  <a:tcPr marL="91440" marR="91440" marT="45720" marB="45720" anchor="ctr">
+                    <a:lnL w="6350" cap="flat" cmpd="sng" algn="ctr">
+                      <a:solidFill>
+                        <a:srgbClr val="DCE4EC"/>
+                      </a:solidFill>
+                      <a:prstDash val="solid"/>
+                      <a:round/>
+                      <a:headEnd type="none" w="med" len="med"/>
+                      <a:tailEnd type="none" w="med" len="med"/>
+                    </a:lnL>
+                    <a:lnR w="6350" cap="flat" cmpd="sng" algn="ctr">
+                      <a:solidFill>
+                        <a:srgbClr val="DCE4EC"/>
+                      </a:solidFill>
+                      <a:prstDash val="solid"/>
+                      <a:round/>
+                      <a:headEnd type="none" w="med" len="med"/>
+                      <a:tailEnd type="none" w="med" len="med"/>
+                    </a:lnR>
+                    <a:lnT w="6350" cap="flat" cmpd="sng" algn="ctr">
+                      <a:solidFill>
+                        <a:srgbClr val="DCE4EC"/>
+                      </a:solidFill>
+                      <a:prstDash val="solid"/>
+                      <a:round/>
+                      <a:headEnd type="none" w="med" len="med"/>
+                      <a:tailEnd type="none" w="med" len="med"/>
+                    </a:lnT>
+                    <a:lnB w="6350" cap="flat" cmpd="sng" algn="ctr">
+                      <a:solidFill>
+                        <a:srgbClr val="DCE4EC"/>
+                      </a:solidFill>
+                      <a:prstDash val="solid"/>
+                      <a:round/>
+                      <a:headEnd type="none" w="med" len="med"/>
+                      <a:tailEnd type="none" w="med" len="med"/>
+                    </a:lnB>
+                  </a:tcPr>
+                </a:tc>
+                <a:tc>
+                  <a:txBody>
+                    <a:bodyPr/>
+                    <a:lstStyle/>
+                    <a:p>
+                      <a:pPr algn="r" indent="0" marL="0">
+                        <a:buNone/>
+                      </a:pPr>
+                      <a:r>
+                        <a:rPr lang="en-US" sz="1000" dirty="0">
+                          <a:solidFill>
+                            <a:srgbClr val="12212E"/>
+                          </a:solidFill>
+                          <a:latin typeface="Calibri" pitchFamily="34" charset="0"/>
+                          <a:ea typeface="Calibri" pitchFamily="34" charset="-122"/>
+                          <a:cs typeface="Calibri" pitchFamily="34" charset="-120"/>
+                        </a:rPr>
+                        <a:t>3/3</a:t>
+                      </a:r>
+                      <a:endParaRPr lang="en-US" sz="1000" dirty="0">
+                        <a:latin typeface="Calibri" charset="0"/>
+                        <a:ea typeface="Calibri" charset="0"/>
+                        <a:cs typeface="Calibri" charset="0"/>
+                      </a:endParaRPr>
+                    </a:p>
+                  </a:txBody>
+                  <a:tcPr marL="91440" marR="91440" marT="45720" marB="45720" anchor="ctr">
+                    <a:lnL w="6350" cap="flat" cmpd="sng" algn="ctr">
+                      <a:solidFill>
+                        <a:srgbClr val="DCE4EC"/>
+                      </a:solidFill>
+                      <a:prstDash val="solid"/>
+                      <a:round/>
+                      <a:headEnd type="none" w="med" len="med"/>
+                      <a:tailEnd type="none" w="med" len="med"/>
+                    </a:lnL>
+                    <a:lnR w="6350" cap="flat" cmpd="sng" algn="ctr">
+                      <a:solidFill>
+                        <a:srgbClr val="DCE4EC"/>
+                      </a:solidFill>
+                      <a:prstDash val="solid"/>
+                      <a:round/>
+                      <a:headEnd type="none" w="med" len="med"/>
+                      <a:tailEnd type="none" w="med" len="med"/>
+                    </a:lnR>
+                    <a:lnT w="6350" cap="flat" cmpd="sng" algn="ctr">
+                      <a:solidFill>
+                        <a:srgbClr val="DCE4EC"/>
+                      </a:solidFill>
+                      <a:prstDash val="solid"/>
+                      <a:round/>
+                      <a:headEnd type="none" w="med" len="med"/>
+                      <a:tailEnd type="none" w="med" len="med"/>
+                    </a:lnT>
+                    <a:lnB w="6350" cap="flat" cmpd="sng" algn="ctr">
+                      <a:solidFill>
+                        <a:srgbClr val="DCE4EC"/>
+                      </a:solidFill>
+                      <a:prstDash val="solid"/>
+                      <a:round/>
+                      <a:headEnd type="none" w="med" len="med"/>
+                      <a:tailEnd type="none" w="med" len="med"/>
+                    </a:lnB>
+                  </a:tcPr>
+                </a:tc>
+                <a:tc>
+                  <a:txBody>
+                    <a:bodyPr/>
+                    <a:lstStyle/>
+                    <a:p>
+                      <a:pPr algn="r" indent="0" marL="0">
+                        <a:buNone/>
+                      </a:pPr>
+                      <a:r>
+                        <a:rPr lang="en-US" sz="1000" dirty="0">
+                          <a:solidFill>
+                            <a:srgbClr val="12212E"/>
+                          </a:solidFill>
+                          <a:latin typeface="Calibri" pitchFamily="34" charset="0"/>
+                          <a:ea typeface="Calibri" pitchFamily="34" charset="-122"/>
+                          <a:cs typeface="Calibri" pitchFamily="34" charset="-120"/>
+                        </a:rPr>
+                        <a:t>1.19</a:t>
+                      </a:r>
+                      <a:endParaRPr lang="en-US" sz="1000" dirty="0">
+                        <a:latin typeface="Calibri" charset="0"/>
+                        <a:ea typeface="Calibri" charset="0"/>
+                        <a:cs typeface="Calibri" charset="0"/>
+                      </a:endParaRPr>
+                    </a:p>
+                  </a:txBody>
+                  <a:tcPr marL="91440" marR="91440" marT="45720" marB="45720" anchor="ctr">
+                    <a:lnL w="6350" cap="flat" cmpd="sng" algn="ctr">
+                      <a:solidFill>
+                        <a:srgbClr val="DCE4EC"/>
+                      </a:solidFill>
+                      <a:prstDash val="solid"/>
+                      <a:round/>
+                      <a:headEnd type="none" w="med" len="med"/>
+                      <a:tailEnd type="none" w="med" len="med"/>
+                    </a:lnL>
+                    <a:lnR w="6350" cap="flat" cmpd="sng" algn="ctr">
+                      <a:solidFill>
+                        <a:srgbClr val="DCE4EC"/>
+                      </a:solidFill>
+                      <a:prstDash val="solid"/>
+                      <a:round/>
+                      <a:headEnd type="none" w="med" len="med"/>
+                      <a:tailEnd type="none" w="med" len="med"/>
+                    </a:lnR>
+                    <a:lnT w="6350" cap="flat" cmpd="sng" algn="ctr">
+                      <a:solidFill>
+                        <a:srgbClr val="DCE4EC"/>
+                      </a:solidFill>
+                      <a:prstDash val="solid"/>
+                      <a:round/>
+                      <a:headEnd type="none" w="med" len="med"/>
+                      <a:tailEnd type="none" w="med" len="med"/>
+                    </a:lnT>
+                    <a:lnB w="6350" cap="flat" cmpd="sng" algn="ctr">
+                      <a:solidFill>
+                        <a:srgbClr val="DCE4EC"/>
+                      </a:solidFill>
+                      <a:prstDash val="solid"/>
+                      <a:round/>
+                      <a:headEnd type="none" w="med" len="med"/>
+                      <a:tailEnd type="none" w="med" len="med"/>
+                    </a:lnB>
+                  </a:tcPr>
+                </a:tc>
+                <a:tc>
+                  <a:txBody>
+                    <a:bodyPr/>
+                    <a:lstStyle/>
+                    <a:p>
+                      <a:pPr algn="r" indent="0" marL="0">
+                        <a:buNone/>
+                      </a:pPr>
+                      <a:r>
+                        <a:rPr lang="en-US" sz="1000" b="1" dirty="0">
+                          <a:solidFill>
+                            <a:srgbClr val="12212E"/>
+                          </a:solidFill>
+                          <a:latin typeface="Calibri" pitchFamily="34" charset="0"/>
+                          <a:ea typeface="Calibri" pitchFamily="34" charset="-122"/>
+                          <a:cs typeface="Calibri" pitchFamily="34" charset="-120"/>
+                        </a:rPr>
+                        <a:t>0.00</a:t>
+                      </a:r>
+                      <a:endParaRPr lang="en-US" sz="1000" dirty="0">
+                        <a:latin typeface="Calibri" charset="0"/>
+                        <a:ea typeface="Calibri" charset="0"/>
+                        <a:cs typeface="Calibri" charset="0"/>
+                      </a:endParaRPr>
+                    </a:p>
+                  </a:txBody>
+                  <a:tcPr marL="91440" marR="91440" marT="45720" marB="45720" anchor="ctr">
+                    <a:lnL w="6350" cap="flat" cmpd="sng" algn="ctr">
+                      <a:solidFill>
+                        <a:srgbClr val="DCE4EC"/>
+                      </a:solidFill>
+                      <a:prstDash val="solid"/>
+                      <a:round/>
+                      <a:headEnd type="none" w="med" len="med"/>
+                      <a:tailEnd type="none" w="med" len="med"/>
+                    </a:lnL>
+                    <a:lnR w="6350" cap="flat" cmpd="sng" algn="ctr">
+                      <a:solidFill>
+                        <a:srgbClr val="DCE4EC"/>
+                      </a:solidFill>
+                      <a:prstDash val="solid"/>
+                      <a:round/>
+                      <a:headEnd type="none" w="med" len="med"/>
+                      <a:tailEnd type="none" w="med" len="med"/>
+                    </a:lnR>
+                    <a:lnT w="6350" cap="flat" cmpd="sng" algn="ctr">
+                      <a:solidFill>
+                        <a:srgbClr val="DCE4EC"/>
+                      </a:solidFill>
+                      <a:prstDash val="solid"/>
+                      <a:round/>
+                      <a:headEnd type="none" w="med" len="med"/>
+                      <a:tailEnd type="none" w="med" len="med"/>
+                    </a:lnT>
+                    <a:lnB w="6350" cap="flat" cmpd="sng" algn="ctr">
+                      <a:solidFill>
+                        <a:srgbClr val="DCE4EC"/>
+                      </a:solidFill>
+                      <a:prstDash val="solid"/>
+                      <a:round/>
+                      <a:headEnd type="none" w="med" len="med"/>
+                      <a:tailEnd type="none" w="med" len="med"/>
+                    </a:lnB>
+                  </a:tcPr>
+                </a:tc>
+              </a:tr>
+              <a:tr h="347472">
+                <a:tc>
+                  <a:txBody>
+                    <a:bodyPr/>
+                    <a:lstStyle/>
+                    <a:p>
+                      <a:pPr indent="0" marL="0">
+                        <a:buNone/>
+                      </a:pPr>
+                      <a:r>
+                        <a:rPr lang="en-US" sz="900" b="1" dirty="0">
+                          <a:solidFill>
+                            <a:srgbClr val="12212E"/>
+                          </a:solidFill>
+                          <a:latin typeface="Courier New" pitchFamily="34" charset="0"/>
+                          <a:ea typeface="Courier New" pitchFamily="34" charset="-122"/>
+                          <a:cs typeface="Courier New" pitchFamily="34" charset="-120"/>
+                        </a:rPr>
+                        <a:t>CLIP_87_101</a:t>
+                      </a:r>
+                      <a:endParaRPr lang="en-US" sz="900" dirty="0">
+                        <a:latin typeface="Courier New" charset="0"/>
+                        <a:ea typeface="Courier New" charset="0"/>
+                        <a:cs typeface="Courier New" charset="0"/>
+                      </a:endParaRPr>
+                    </a:p>
+                  </a:txBody>
+                  <a:tcPr marL="91440" marR="91440" marT="45720" marB="45720" anchor="ctr">
+                    <a:lnL w="6350" cap="flat" cmpd="sng" algn="ctr">
+                      <a:solidFill>
+                        <a:srgbClr val="DCE4EC"/>
+                      </a:solidFill>
+                      <a:prstDash val="solid"/>
+                      <a:round/>
+                      <a:headEnd type="none" w="med" len="med"/>
+                      <a:tailEnd type="none" w="med" len="med"/>
+                    </a:lnL>
+                    <a:lnR w="6350" cap="flat" cmpd="sng" algn="ctr">
+                      <a:solidFill>
+                        <a:srgbClr val="DCE4EC"/>
+                      </a:solidFill>
+                      <a:prstDash val="solid"/>
+                      <a:round/>
+                      <a:headEnd type="none" w="med" len="med"/>
+                      <a:tailEnd type="none" w="med" len="med"/>
+                    </a:lnR>
+                    <a:lnT w="6350" cap="flat" cmpd="sng" algn="ctr">
+                      <a:solidFill>
+                        <a:srgbClr val="DCE4EC"/>
+                      </a:solidFill>
+                      <a:prstDash val="solid"/>
+                      <a:round/>
+                      <a:headEnd type="none" w="med" len="med"/>
+                      <a:tailEnd type="none" w="med" len="med"/>
+                    </a:lnT>
+                    <a:lnB w="6350" cap="flat" cmpd="sng" algn="ctr">
+                      <a:solidFill>
+                        <a:srgbClr val="DCE4EC"/>
+                      </a:solidFill>
+                      <a:prstDash val="solid"/>
+                      <a:round/>
+                      <a:headEnd type="none" w="med" len="med"/>
+                      <a:tailEnd type="none" w="med" len="med"/>
+                    </a:lnB>
+                  </a:tcPr>
+                </a:tc>
+                <a:tc>
+                  <a:txBody>
+                    <a:bodyPr/>
+                    <a:lstStyle/>
+                    <a:p>
+                      <a:pPr indent="0" marL="0">
+                        <a:buNone/>
+                      </a:pPr>
+                      <a:r>
+                        <a:rPr lang="en-US" sz="900" dirty="0">
+                          <a:solidFill>
+                            <a:srgbClr val="C9752B"/>
+                          </a:solidFill>
+                          <a:latin typeface="Calibri" pitchFamily="34" charset="0"/>
+                          <a:ea typeface="Calibri" pitchFamily="34" charset="-122"/>
+                          <a:cs typeface="Calibri" pitchFamily="34" charset="-120"/>
+                        </a:rPr>
+                        <a:t>tolerised binder control</a:t>
+                      </a:r>
+                      <a:endParaRPr lang="en-US" sz="900" dirty="0">
+                        <a:latin typeface="Calibri" charset="0"/>
+                        <a:ea typeface="Calibri" charset="0"/>
+                        <a:cs typeface="Calibri" charset="0"/>
+                      </a:endParaRPr>
+                    </a:p>
+                  </a:txBody>
+                  <a:tcPr marL="91440" marR="91440" marT="45720" marB="45720" anchor="ctr">
+                    <a:lnL w="6350" cap="flat" cmpd="sng" algn="ctr">
+                      <a:solidFill>
+                        <a:srgbClr val="DCE4EC"/>
+                      </a:solidFill>
+                      <a:prstDash val="solid"/>
+                      <a:round/>
+                      <a:headEnd type="none" w="med" len="med"/>
+                      <a:tailEnd type="none" w="med" len="med"/>
+                    </a:lnL>
+                    <a:lnR w="6350" cap="flat" cmpd="sng" algn="ctr">
+                      <a:solidFill>
+                        <a:srgbClr val="DCE4EC"/>
+                      </a:solidFill>
+                      <a:prstDash val="solid"/>
+                      <a:round/>
+                      <a:headEnd type="none" w="med" len="med"/>
+                      <a:tailEnd type="none" w="med" len="med"/>
+                    </a:lnR>
+                    <a:lnT w="6350" cap="flat" cmpd="sng" algn="ctr">
+                      <a:solidFill>
+                        <a:srgbClr val="DCE4EC"/>
+                      </a:solidFill>
+                      <a:prstDash val="solid"/>
+                      <a:round/>
+                      <a:headEnd type="none" w="med" len="med"/>
+                      <a:tailEnd type="none" w="med" len="med"/>
+                    </a:lnT>
+                    <a:lnB w="6350" cap="flat" cmpd="sng" algn="ctr">
+                      <a:solidFill>
+                        <a:srgbClr val="DCE4EC"/>
+                      </a:solidFill>
+                      <a:prstDash val="solid"/>
+                      <a:round/>
+                      <a:headEnd type="none" w="med" len="med"/>
+                      <a:tailEnd type="none" w="med" len="med"/>
+                    </a:lnB>
+                  </a:tcPr>
+                </a:tc>
+                <a:tc>
+                  <a:txBody>
+                    <a:bodyPr/>
+                    <a:lstStyle/>
+                    <a:p>
+                      <a:pPr algn="r" indent="0" marL="0">
+                        <a:buNone/>
+                      </a:pPr>
+                      <a:r>
+                        <a:rPr lang="en-US" sz="1000" dirty="0">
+                          <a:solidFill>
+                            <a:srgbClr val="12212E"/>
+                          </a:solidFill>
+                          <a:latin typeface="Calibri" pitchFamily="34" charset="0"/>
+                          <a:ea typeface="Calibri" pitchFamily="34" charset="-122"/>
+                          <a:cs typeface="Calibri" pitchFamily="34" charset="-120"/>
+                        </a:rPr>
+                        <a:t>1/25</a:t>
+                      </a:r>
+                      <a:endParaRPr lang="en-US" sz="1000" dirty="0">
+                        <a:latin typeface="Calibri" charset="0"/>
+                        <a:ea typeface="Calibri" charset="0"/>
+                        <a:cs typeface="Calibri" charset="0"/>
+                      </a:endParaRPr>
+                    </a:p>
+                  </a:txBody>
+                  <a:tcPr marL="91440" marR="91440" marT="45720" marB="45720" anchor="ctr">
+                    <a:lnL w="6350" cap="flat" cmpd="sng" algn="ctr">
+                      <a:solidFill>
+                        <a:srgbClr val="DCE4EC"/>
+                      </a:solidFill>
+                      <a:prstDash val="solid"/>
+                      <a:round/>
+                      <a:headEnd type="none" w="med" len="med"/>
+                      <a:tailEnd type="none" w="med" len="med"/>
+                    </a:lnL>
+                    <a:lnR w="6350" cap="flat" cmpd="sng" algn="ctr">
+                      <a:solidFill>
+                        <a:srgbClr val="DCE4EC"/>
+                      </a:solidFill>
+                      <a:prstDash val="solid"/>
+                      <a:round/>
+                      <a:headEnd type="none" w="med" len="med"/>
+                      <a:tailEnd type="none" w="med" len="med"/>
+                    </a:lnR>
+                    <a:lnT w="6350" cap="flat" cmpd="sng" algn="ctr">
+                      <a:solidFill>
+                        <a:srgbClr val="DCE4EC"/>
+                      </a:solidFill>
+                      <a:prstDash val="solid"/>
+                      <a:round/>
+                      <a:headEnd type="none" w="med" len="med"/>
+                      <a:tailEnd type="none" w="med" len="med"/>
+                    </a:lnT>
+                    <a:lnB w="6350" cap="flat" cmpd="sng" algn="ctr">
+                      <a:solidFill>
+                        <a:srgbClr val="DCE4EC"/>
+                      </a:solidFill>
+                      <a:prstDash val="solid"/>
+                      <a:round/>
+                      <a:headEnd type="none" w="med" len="med"/>
+                      <a:tailEnd type="none" w="med" len="med"/>
+                    </a:lnB>
+                  </a:tcPr>
+                </a:tc>
+                <a:tc>
+                  <a:txBody>
+                    <a:bodyPr/>
+                    <a:lstStyle/>
+                    <a:p>
+                      <a:pPr algn="r" indent="0" marL="0">
+                        <a:buNone/>
+                      </a:pPr>
+                      <a:r>
+                        <a:rPr lang="en-US" sz="1000" dirty="0">
+                          <a:solidFill>
+                            <a:srgbClr val="12212E"/>
+                          </a:solidFill>
+                          <a:latin typeface="Calibri" pitchFamily="34" charset="0"/>
+                          <a:ea typeface="Calibri" pitchFamily="34" charset="-122"/>
+                          <a:cs typeface="Calibri" pitchFamily="34" charset="-120"/>
+                        </a:rPr>
+                        <a:t>7/25</a:t>
+                      </a:r>
+                      <a:endParaRPr lang="en-US" sz="1000" dirty="0">
+                        <a:latin typeface="Calibri" charset="0"/>
+                        <a:ea typeface="Calibri" charset="0"/>
+                        <a:cs typeface="Calibri" charset="0"/>
+                      </a:endParaRPr>
+                    </a:p>
+                  </a:txBody>
+                  <a:tcPr marL="91440" marR="91440" marT="45720" marB="45720" anchor="ctr">
+                    <a:lnL w="6350" cap="flat" cmpd="sng" algn="ctr">
+                      <a:solidFill>
+                        <a:srgbClr val="DCE4EC"/>
+                      </a:solidFill>
+                      <a:prstDash val="solid"/>
+                      <a:round/>
+                      <a:headEnd type="none" w="med" len="med"/>
+                      <a:tailEnd type="none" w="med" len="med"/>
+                    </a:lnL>
+                    <a:lnR w="6350" cap="flat" cmpd="sng" algn="ctr">
+                      <a:solidFill>
+                        <a:srgbClr val="DCE4EC"/>
+                      </a:solidFill>
+                      <a:prstDash val="solid"/>
+                      <a:round/>
+                      <a:headEnd type="none" w="med" len="med"/>
+                      <a:tailEnd type="none" w="med" len="med"/>
+                    </a:lnR>
+                    <a:lnT w="6350" cap="flat" cmpd="sng" algn="ctr">
+                      <a:solidFill>
+                        <a:srgbClr val="DCE4EC"/>
+                      </a:solidFill>
+                      <a:prstDash val="solid"/>
+                      <a:round/>
+                      <a:headEnd type="none" w="med" len="med"/>
+                      <a:tailEnd type="none" w="med" len="med"/>
+                    </a:lnT>
+                    <a:lnB w="6350" cap="flat" cmpd="sng" algn="ctr">
+                      <a:solidFill>
+                        <a:srgbClr val="DCE4EC"/>
+                      </a:solidFill>
+                      <a:prstDash val="solid"/>
+                      <a:round/>
+                      <a:headEnd type="none" w="med" len="med"/>
+                      <a:tailEnd type="none" w="med" len="med"/>
+                    </a:lnB>
+                  </a:tcPr>
+                </a:tc>
+                <a:tc>
+                  <a:txBody>
+                    <a:bodyPr/>
+                    <a:lstStyle/>
+                    <a:p>
+                      <a:pPr algn="r" indent="0" marL="0">
+                        <a:buNone/>
+                      </a:pPr>
+                      <a:r>
+                        <a:rPr lang="en-US" sz="1000" dirty="0">
+                          <a:solidFill>
+                            <a:srgbClr val="12212E"/>
+                          </a:solidFill>
+                          <a:latin typeface="Calibri" pitchFamily="34" charset="0"/>
+                          <a:ea typeface="Calibri" pitchFamily="34" charset="-122"/>
+                          <a:cs typeface="Calibri" pitchFamily="34" charset="-120"/>
+                        </a:rPr>
+                        <a:t>1/1</a:t>
+                      </a:r>
+                      <a:endParaRPr lang="en-US" sz="1000" dirty="0">
+                        <a:latin typeface="Calibri" charset="0"/>
+                        <a:ea typeface="Calibri" charset="0"/>
+                        <a:cs typeface="Calibri" charset="0"/>
+                      </a:endParaRPr>
+                    </a:p>
+                  </a:txBody>
+                  <a:tcPr marL="91440" marR="91440" marT="45720" marB="45720" anchor="ctr">
+                    <a:lnL w="6350" cap="flat" cmpd="sng" algn="ctr">
+                      <a:solidFill>
+                        <a:srgbClr val="DCE4EC"/>
+                      </a:solidFill>
+                      <a:prstDash val="solid"/>
+                      <a:round/>
+                      <a:headEnd type="none" w="med" len="med"/>
+                      <a:tailEnd type="none" w="med" len="med"/>
+                    </a:lnL>
+                    <a:lnR w="6350" cap="flat" cmpd="sng" algn="ctr">
+                      <a:solidFill>
+                        <a:srgbClr val="DCE4EC"/>
+                      </a:solidFill>
+                      <a:prstDash val="solid"/>
+                      <a:round/>
+                      <a:headEnd type="none" w="med" len="med"/>
+                      <a:tailEnd type="none" w="med" len="med"/>
+                    </a:lnR>
+                    <a:lnT w="6350" cap="flat" cmpd="sng" algn="ctr">
+                      <a:solidFill>
+                        <a:srgbClr val="DCE4EC"/>
+                      </a:solidFill>
+                      <a:prstDash val="solid"/>
+                      <a:round/>
+                      <a:headEnd type="none" w="med" len="med"/>
+                      <a:tailEnd type="none" w="med" len="med"/>
+                    </a:lnT>
+                    <a:lnB w="6350" cap="flat" cmpd="sng" algn="ctr">
+                      <a:solidFill>
+                        <a:srgbClr val="DCE4EC"/>
+                      </a:solidFill>
+                      <a:prstDash val="solid"/>
+                      <a:round/>
+                      <a:headEnd type="none" w="med" len="med"/>
+                      <a:tailEnd type="none" w="med" len="med"/>
+                    </a:lnB>
+                  </a:tcPr>
+                </a:tc>
+                <a:tc>
+                  <a:txBody>
+                    <a:bodyPr/>
+                    <a:lstStyle/>
+                    <a:p>
+                      <a:pPr algn="r" indent="0" marL="0">
+                        <a:buNone/>
+                      </a:pPr>
+                      <a:r>
+                        <a:rPr lang="en-US" sz="1000" dirty="0">
+                          <a:solidFill>
+                            <a:srgbClr val="12212E"/>
+                          </a:solidFill>
+                          <a:latin typeface="Calibri" pitchFamily="34" charset="0"/>
+                          <a:ea typeface="Calibri" pitchFamily="34" charset="-122"/>
+                          <a:cs typeface="Calibri" pitchFamily="34" charset="-120"/>
+                        </a:rPr>
+                        <a:t>0.00</a:t>
+                      </a:r>
+                      <a:endParaRPr lang="en-US" sz="1000" dirty="0">
+                        <a:latin typeface="Calibri" charset="0"/>
+                        <a:ea typeface="Calibri" charset="0"/>
+                        <a:cs typeface="Calibri" charset="0"/>
+                      </a:endParaRPr>
+                    </a:p>
+                  </a:txBody>
+                  <a:tcPr marL="91440" marR="91440" marT="45720" marB="45720" anchor="ctr">
+                    <a:lnL w="6350" cap="flat" cmpd="sng" algn="ctr">
+                      <a:solidFill>
+                        <a:srgbClr val="DCE4EC"/>
+                      </a:solidFill>
+                      <a:prstDash val="solid"/>
+                      <a:round/>
+                      <a:headEnd type="none" w="med" len="med"/>
+                      <a:tailEnd type="none" w="med" len="med"/>
+                    </a:lnL>
+                    <a:lnR w="6350" cap="flat" cmpd="sng" algn="ctr">
+                      <a:solidFill>
+                        <a:srgbClr val="DCE4EC"/>
+                      </a:solidFill>
+                      <a:prstDash val="solid"/>
+                      <a:round/>
+                      <a:headEnd type="none" w="med" len="med"/>
+                      <a:tailEnd type="none" w="med" len="med"/>
+                    </a:lnR>
+                    <a:lnT w="6350" cap="flat" cmpd="sng" algn="ctr">
+                      <a:solidFill>
+                        <a:srgbClr val="DCE4EC"/>
+                      </a:solidFill>
+                      <a:prstDash val="solid"/>
+                      <a:round/>
+                      <a:headEnd type="none" w="med" len="med"/>
+                      <a:tailEnd type="none" w="med" len="med"/>
+                    </a:lnT>
+                    <a:lnB w="6350" cap="flat" cmpd="sng" algn="ctr">
+                      <a:solidFill>
+                        <a:srgbClr val="DCE4EC"/>
+                      </a:solidFill>
+                      <a:prstDash val="solid"/>
+                      <a:round/>
+                      <a:headEnd type="none" w="med" len="med"/>
+                      <a:tailEnd type="none" w="med" len="med"/>
+                    </a:lnB>
+                  </a:tcPr>
+                </a:tc>
+                <a:tc>
+                  <a:txBody>
+                    <a:bodyPr/>
+                    <a:lstStyle/>
+                    <a:p>
+                      <a:pPr algn="r" indent="0" marL="0">
+                        <a:buNone/>
+                      </a:pPr>
+                      <a:r>
+                        <a:rPr lang="en-US" sz="1000" b="1" dirty="0">
+                          <a:solidFill>
+                            <a:srgbClr val="12212E"/>
+                          </a:solidFill>
+                          <a:latin typeface="Calibri" pitchFamily="34" charset="0"/>
+                          <a:ea typeface="Calibri" pitchFamily="34" charset="-122"/>
+                          <a:cs typeface="Calibri" pitchFamily="34" charset="-120"/>
+                        </a:rPr>
+                        <a:t>0.00</a:t>
+                      </a:r>
+                      <a:endParaRPr lang="en-US" sz="1000" dirty="0">
+                        <a:latin typeface="Calibri" charset="0"/>
+                        <a:ea typeface="Calibri" charset="0"/>
+                        <a:cs typeface="Calibri" charset="0"/>
+                      </a:endParaRPr>
+                    </a:p>
+                  </a:txBody>
+                  <a:tcPr marL="91440" marR="91440" marT="45720" marB="45720" anchor="ctr">
+                    <a:lnL w="6350" cap="flat" cmpd="sng" algn="ctr">
+                      <a:solidFill>
+                        <a:srgbClr val="DCE4EC"/>
+                      </a:solidFill>
+                      <a:prstDash val="solid"/>
+                      <a:round/>
+                      <a:headEnd type="none" w="med" len="med"/>
+                      <a:tailEnd type="none" w="med" len="med"/>
+                    </a:lnL>
+                    <a:lnR w="6350" cap="flat" cmpd="sng" algn="ctr">
+                      <a:solidFill>
+                        <a:srgbClr val="DCE4EC"/>
+                      </a:solidFill>
+                      <a:prstDash val="solid"/>
+                      <a:round/>
+                      <a:headEnd type="none" w="med" len="med"/>
+                      <a:tailEnd type="none" w="med" len="med"/>
+                    </a:lnR>
+                    <a:lnT w="6350" cap="flat" cmpd="sng" algn="ctr">
+                      <a:solidFill>
+                        <a:srgbClr val="DCE4EC"/>
+                      </a:solidFill>
+                      <a:prstDash val="solid"/>
+                      <a:round/>
+                      <a:headEnd type="none" w="med" len="med"/>
+                      <a:tailEnd type="none" w="med" len="med"/>
+                    </a:lnT>
+                    <a:lnB w="6350" cap="flat" cmpd="sng" algn="ctr">
+                      <a:solidFill>
+                        <a:srgbClr val="DCE4EC"/>
+                      </a:solidFill>
+                      <a:prstDash val="solid"/>
+                      <a:round/>
+                      <a:headEnd type="none" w="med" len="med"/>
+                      <a:tailEnd type="none" w="med" len="med"/>
+                    </a:lnB>
+                  </a:tcPr>
+                </a:tc>
+              </a:tr>
+            </a:tbl>
+          </a:graphicData>
+        </a:graphic>
+      </p:graphicFrame>
+      <p:sp>
+        <p:nvSpPr>
+          <p:cNvPr id="6" name="Shape 3"/>
+          <p:cNvSpPr/>
+          <p:nvPr/>
+        </p:nvSpPr>
+        <p:spPr>
+          <a:xfrm>
+            <a:off x="566928" y="3017520"/>
+            <a:ext cx="11027664" cy="1783080"/>
+          </a:xfrm>
+          <a:prstGeom prst="roundRect">
+            <a:avLst>
+              <a:gd name="adj" fmla="val 3077"/>
+            </a:avLst>
+          </a:prstGeom>
+          <a:solidFill>
+            <a:srgbClr val="FBF1F1"/>
+          </a:solidFill>
+          <a:ln w="9525">
+            <a:solidFill>
+              <a:srgbClr val="E8CDCD"/>
+            </a:solidFill>
+            <a:prstDash val="solid"/>
+          </a:ln>
+        </p:spPr>
+      </p:sp>
+      <p:sp>
+        <p:nvSpPr>
+          <p:cNvPr id="7" name="Text 4"/>
+          <p:cNvSpPr/>
+          <p:nvPr/>
+        </p:nvSpPr>
+        <p:spPr>
+          <a:xfrm>
+            <a:off x="768096" y="3127248"/>
+            <a:ext cx="10625328" cy="1572768"/>
+          </a:xfrm>
+          <a:prstGeom prst="rect">
+            <a:avLst/>
+          </a:prstGeom>
+          <a:noFill/>
+          <a:ln/>
+        </p:spPr>
+        <p:txBody>
+          <a:bodyPr wrap="square" lIns="0" tIns="0" rIns="0" bIns="0" rtlCol="0" anchor="ctr"/>
+          <a:lstStyle/>
+          <a:p>
+            <a:pPr indent="0" marL="0">
+              <a:lnSpc>
+                <a:spcPts val="1400"/>
+              </a:lnSpc>
+              <a:buNone/>
+            </a:pPr>
+            <a:r>
+              <a:rPr lang="en-US" sz="1100" b="1" dirty="0">
+                <a:solidFill>
+                  <a:srgbClr val="B23B3B"/>
+                </a:solidFill>
+                <a:latin typeface="Calibri" pitchFamily="34" charset="0"/>
+                <a:ea typeface="Calibri" pitchFamily="34" charset="-122"/>
+                <a:cs typeface="Calibri" pitchFamily="34" charset="-120"/>
+              </a:rPr>
+              <a:t>The filter suppresses a real epitope, and this is the clearest example.
+</a:t>
+            </a:r>
+            <a:pPr indent="0" marL="0">
+              <a:lnSpc>
+                <a:spcPts val="1400"/>
+              </a:lnSpc>
+              <a:buNone/>
+            </a:pPr>
+            <a:r>
+              <a:rPr lang="en-US" sz="1100" dirty="0">
+                <a:solidFill>
+                  <a:srgbClr val="12212E"/>
+                </a:solidFill>
+                <a:latin typeface="Calibri" pitchFamily="34" charset="0"/>
+                <a:ea typeface="Calibri" pitchFamily="34" charset="-122"/>
+                <a:cs typeface="Calibri" pitchFamily="34" charset="-120"/>
+              </a:rPr>
+              <a:t>Myelin basic protein 85–99 is a human self peptide with positive DR-restricted T-cell assays on 10 distinct DR molecules in IEDB. On this panel it is the broadest binder in the entire batch — 10/25 DR molecules at the strong-binder tier, unfiltered pIRS 1.19, higher than any ligand here. The tolerance filter takes it to 0.00.</a:t>
+            </a:r>
+            <a:endParaRPr lang="en-US" sz="1100" dirty="0"/>
+          </a:p>
+          <a:p>
+            <a:pPr indent="0" marL="0">
+              <a:lnSpc>
+                <a:spcPts val="1400"/>
+              </a:lnSpc>
+              <a:buNone/>
+            </a:pPr>
+            <a:endParaRPr lang="en-US" sz="1100" dirty="0"/>
+          </a:p>
+          <a:p>
+            <a:pPr indent="0" marL="0">
+              <a:lnSpc>
+                <a:spcPts val="1400"/>
+              </a:lnSpc>
+              <a:buNone/>
+            </a:pPr>
+            <a:r>
+              <a:rPr lang="en-US" sz="1100" dirty="0">
+                <a:solidFill>
+                  <a:srgbClr val="12212E"/>
+                </a:solidFill>
+                <a:latin typeface="Calibri" pitchFamily="34" charset="0"/>
+                <a:ea typeface="Calibri" pitchFamily="34" charset="-122"/>
+                <a:cs typeface="Calibri" pitchFamily="34" charset="-120"/>
+              </a:rPr>
+              <a:t>That is the filter working as designed and being wrong. Self-derived epitopes exist — autoimmunity is what they are — and a sequence-identity filter cannot see the difference. It is safe for an affinity ligand because a foreign scaffold's framework similarity to human germline is the case it was built for; it is not safe for anything where self-reactivity is the question.</a:t>
+            </a:r>
+            <a:endParaRPr lang="en-US" sz="1100" dirty="0"/>
+          </a:p>
+        </p:txBody>
+      </p:sp>
+      <p:sp>
+        <p:nvSpPr>
+          <p:cNvPr id="8" name="Text 5"/>
+          <p:cNvSpPr/>
+          <p:nvPr/>
+        </p:nvSpPr>
+        <p:spPr>
+          <a:xfrm>
+            <a:off x="566928" y="4956048"/>
+            <a:ext cx="11027664" cy="658368"/>
+          </a:xfrm>
+          <a:prstGeom prst="rect">
+            <a:avLst/>
+          </a:prstGeom>
+          <a:noFill/>
+          <a:ln/>
+        </p:spPr>
+        <p:txBody>
+          <a:bodyPr wrap="square" lIns="0" tIns="0" rIns="0" bIns="0" rtlCol="0" anchor="ctr"/>
+          <a:lstStyle/>
+          <a:p>
+            <a:pPr indent="0" marL="0">
+              <a:lnSpc>
+                <a:spcPts val="1500"/>
+              </a:lnSpc>
+              <a:buNone/>
+            </a:pPr>
+            <a:r>
+              <a:rPr lang="en-US" sz="1150" dirty="0">
+                <a:solidFill>
+                  <a:srgbClr val="12212E"/>
+                </a:solidFill>
+                <a:latin typeface="Calibri" pitchFamily="34" charset="0"/>
+                <a:ea typeface="Calibri" pitchFamily="34" charset="-122"/>
+                <a:cs typeface="Calibri" pitchFamily="34" charset="-120"/>
+              </a:rPr>
+              <a:t>The opposite control behaves too. CLIP occupies the groove of essentially every DR molecule as the invariant chain's placeholder, yet carries no positive human DR T-cell record in IEDB. Here it reaches 7/25 at the weak tier and 1/25 at the strong tier, and ends at pIRS 0.00 — binding strength alone is not being read as risk.</a:t>
+            </a:r>
+            <a:endParaRPr lang="en-US" sz="1150" dirty="0"/>
+          </a:p>
+        </p:txBody>
+      </p:sp>
+      <p:sp>
+        <p:nvSpPr>
+          <p:cNvPr id="9" name="Text 6"/>
+          <p:cNvSpPr/>
+          <p:nvPr/>
+        </p:nvSpPr>
+        <p:spPr>
+          <a:xfrm>
+            <a:off x="566928" y="5897880"/>
+            <a:ext cx="11027664" cy="502920"/>
+          </a:xfrm>
+          <a:prstGeom prst="rect">
+            <a:avLst/>
+          </a:prstGeom>
+          <a:noFill/>
+          <a:ln/>
+        </p:spPr>
+        <p:txBody>
+          <a:bodyPr wrap="square" lIns="0" tIns="0" rIns="0" bIns="0" rtlCol="0" anchor="ctr"/>
+          <a:lstStyle/>
+          <a:p>
+            <a:pPr indent="0" marL="0">
+              <a:lnSpc>
+                <a:spcPts val="1200"/>
+              </a:lnSpc>
+              <a:buNone/>
+            </a:pPr>
+            <a:r>
+              <a:rPr lang="en-US" sz="950" i="1" dirty="0">
+                <a:solidFill>
+                  <a:srgbClr val="63748A"/>
+                </a:solidFill>
+                <a:latin typeface="Calibri" pitchFamily="34" charset="0"/>
+                <a:ea typeface="Calibri" pitchFamily="34" charset="-122"/>
+                <a:cs typeface="Calibri" pitchFamily="34" charset="-120"/>
+              </a:rPr>
+              <a:t>Both controls' roles were checked against IEDB before assignment. They do not pass or fail the batch — they put a number on two things the filter cannot do.</a:t>
+            </a:r>
+            <a:endParaRPr lang="en-US" sz="950" dirty="0"/>
+          </a:p>
+        </p:txBody>
+      </p:sp>
+    </p:spTree>
+  </p:cSld>
+  <p:clrMapOvr>
+    <a:masterClrMapping/>
+  </p:clrMapOvr>
+</p:sld>
+</file>
+
+<file path=ppt/slides/slide8.xml><?xml version="1.0" encoding="utf-8"?>
+<p:sld xmlns:a="http://schemas.openxmlformats.org/drawingml/2006/main" xmlns:r="http://schemas.openxmlformats.org/officeDocument/2006/relationships" xmlns:p="http://schemas.openxmlformats.org/presentationml/2006/main">
+  <p:cSld name="Slide 8">
+    <p:bg>
+      <p:bgPr>
+        <a:solidFill>
+          <a:srgbClr val="FFFFFF"/>
+        </a:solidFill>
+      </p:bgPr>
+    </p:bg>
+    <p:spTree>
+      <p:nvGrpSpPr>
+        <p:cNvPr id="1" name=""/>
+        <p:cNvGrpSpPr/>
+        <p:nvPr/>
+      </p:nvGrpSpPr>
+      <p:grpSpPr>
+        <a:xfrm>
+          <a:off x="0" y="0"/>
+          <a:ext cx="0" cy="0"/>
+          <a:chOff x="0" y="0"/>
+          <a:chExt cx="0" cy="0"/>
+        </a:xfrm>
+      </p:grpSpPr>
+      <p:sp>
+        <p:nvSpPr>
+          <p:cNvPr id="2" name="Text 0"/>
+          <p:cNvSpPr/>
+          <p:nvPr/>
+        </p:nvSpPr>
+        <p:spPr>
+          <a:xfrm>
+            <a:off x="566928" y="310896"/>
+            <a:ext cx="11027664" cy="219456"/>
+          </a:xfrm>
+          <a:prstGeom prst="rect">
+            <a:avLst/>
+          </a:prstGeom>
+          <a:noFill/>
+          <a:ln/>
+        </p:spPr>
+        <p:txBody>
+          <a:bodyPr wrap="square" lIns="0" tIns="0" rIns="0" bIns="0" rtlCol="0" anchor="ctr"/>
+          <a:lstStyle/>
+          <a:p>
+            <a:pPr indent="0" marL="0">
+              <a:buNone/>
+            </a:pPr>
+            <a:r>
+              <a:rPr lang="en-US" sz="1050" b="1" spc="160" kern="0" dirty="0">
+                <a:solidFill>
+                  <a:srgbClr val="2F6F9F"/>
+                </a:solidFill>
+                <a:latin typeface="Calibri" pitchFamily="34" charset="0"/>
+                <a:ea typeface="Calibri" pitchFamily="34" charset="-122"/>
+                <a:cs typeface="Calibri" pitchFamily="34" charset="-120"/>
+              </a:rPr>
               <a:t>MODULES 5–6 · SCORING</a:t>
             </a:r>
             <a:endParaRPr lang="en-US" sz="1050" dirty="0"/>
@@ -13045,7 +15967,7 @@
       </p:pic>
       <p:graphicFrame>
         <p:nvGraphicFramePr>
-          <p:cNvPr id="8" name="Table 0"/>
+          <p:cNvPr id="9" name="Table 0"/>
           <p:cNvGraphicFramePr>
             <a:graphicFrameLocks noGrp="1"/>
           </p:cNvGraphicFramePr>
@@ -13348,7 +16270,7 @@
                           <a:ea typeface="Calibri" pitchFamily="34" charset="-122"/>
                           <a:cs typeface="Calibri" pitchFamily="34" charset="-120"/>
                         </a:rPr>
-                        <a:t>TT_p2_region 5/25 DR at %Rank&lt;5 (0 at &lt;1, best 1.4); TT_p30_region 5/25 DR at %Rank&lt;5 (2 at &lt;1, best 0.64)</a:t>
+                        <a:t>HA_306_318_region 8/25 DR at %Rank&lt;5 (2 at &lt;1, best 0.46); TT_p2_region 15/25 DR at %Rank&lt;5 (6 at &lt;1, best 0.06); TT_p30_region 5/25 DR at %Rank&lt;5 (2 at &lt;1, best 0.64)</a:t>
                       </a:r>
                       <a:endParaRPr lang="en-US" sz="900" dirty="0">
                         <a:latin typeface="Calibri" charset="0"/>
@@ -13742,7 +16664,7 @@
                           <a:ea typeface="Calibri" pitchFamily="34" charset="-122"/>
                           <a:cs typeface="Calibri" pitchFamily="34" charset="-120"/>
                         </a:rPr>
-                        <a:t>mean score drop: self 100.0% vs ligands 10.6%</a:t>
+                        <a:t>mean score drop: self 100.0% vs ligands 9.1%</a:t>
                       </a:r>
                       <a:endParaRPr lang="en-US" sz="900" dirty="0">
                         <a:latin typeface="Calibri" charset="0"/>
@@ -14065,9 +16987,9 @@
 </p:sld>
 </file>
 
-<file path=ppt/slides/slide8.xml><?xml version="1.0" encoding="utf-8"?>
+<file path=ppt/slides/slide9.xml><?xml version="1.0" encoding="utf-8"?>
 <p:sld xmlns:a="http://schemas.openxmlformats.org/drawingml/2006/main" xmlns:r="http://schemas.openxmlformats.org/officeDocument/2006/relationships" xmlns:p="http://schemas.openxmlformats.org/presentationml/2006/main">
-  <p:cSld name="Slide 8">
+  <p:cSld name="Slide 9">
     <p:bg>
       <p:bgPr>
         <a:solidFill>
@@ -14169,7 +17091,7 @@
       </p:sp>
       <p:graphicFrame>
         <p:nvGraphicFramePr>
-          <p:cNvPr id="9" name="Table 0"/>
+          <p:cNvPr id="10" name="Table 0"/>
           <p:cNvGraphicFramePr>
             <a:graphicFrameLocks noGrp="1"/>
           </p:cNvGraphicFramePr>
@@ -16878,7 +19800,7 @@
       </p:sp>
       <p:graphicFrame>
         <p:nvGraphicFramePr>
-          <p:cNvPr id="17" name="Table 1"/>
+          <p:cNvPr id="19" name="Table 1"/>
           <p:cNvGraphicFramePr>
             <a:graphicFrameLocks noGrp="1"/>
           </p:cNvGraphicFramePr>
@@ -20068,1060 +22990,6 @@
           </a:graphicData>
         </a:graphic>
       </p:graphicFrame>
-    </p:spTree>
-  </p:cSld>
-  <p:clrMapOvr>
-    <a:masterClrMapping/>
-  </p:clrMapOvr>
-</p:sld>
-</file>
-
-<file path=ppt/slides/slide9.xml><?xml version="1.0" encoding="utf-8"?>
-<p:sld xmlns:a="http://schemas.openxmlformats.org/drawingml/2006/main" xmlns:r="http://schemas.openxmlformats.org/officeDocument/2006/relationships" xmlns:p="http://schemas.openxmlformats.org/presentationml/2006/main">
-  <p:cSld name="Slide 9">
-    <p:bg>
-      <p:bgPr>
-        <a:solidFill>
-          <a:srgbClr val="FFFFFF"/>
-        </a:solidFill>
-      </p:bgPr>
-    </p:bg>
-    <p:spTree>
-      <p:nvGrpSpPr>
-        <p:cNvPr id="1" name=""/>
-        <p:cNvGrpSpPr/>
-        <p:nvPr/>
-      </p:nvGrpSpPr>
-      <p:grpSpPr>
-        <a:xfrm>
-          <a:off x="0" y="0"/>
-          <a:ext cx="0" cy="0"/>
-          <a:chOff x="0" y="0"/>
-          <a:chExt cx="0" cy="0"/>
-        </a:xfrm>
-      </p:grpSpPr>
-      <p:sp>
-        <p:nvSpPr>
-          <p:cNvPr id="2" name="Text 0"/>
-          <p:cNvSpPr/>
-          <p:nvPr/>
-        </p:nvSpPr>
-        <p:spPr>
-          <a:xfrm>
-            <a:off x="566928" y="310896"/>
-            <a:ext cx="11027664" cy="219456"/>
-          </a:xfrm>
-          <a:prstGeom prst="rect">
-            <a:avLst/>
-          </a:prstGeom>
-          <a:noFill/>
-          <a:ln/>
-        </p:spPr>
-        <p:txBody>
-          <a:bodyPr wrap="square" lIns="0" tIns="0" rIns="0" bIns="0" rtlCol="0" anchor="ctr"/>
-          <a:lstStyle/>
-          <a:p>
-            <a:pPr indent="0" marL="0">
-              <a:buNone/>
-            </a:pPr>
-            <a:r>
-              <a:rPr lang="en-US" sz="1050" b="1" spc="160" kern="0" dirty="0">
-                <a:solidFill>
-                  <a:srgbClr val="2F6F9F"/>
-                </a:solidFill>
-                <a:latin typeface="Calibri" pitchFamily="34" charset="0"/>
-                <a:ea typeface="Calibri" pitchFamily="34" charset="-122"/>
-                <a:cs typeface="Calibri" pitchFamily="34" charset="-120"/>
-              </a:rPr>
-              <a:t>MODULE 7 · ADA LAYER</a:t>
-            </a:r>
-            <a:endParaRPr lang="en-US" sz="1050" dirty="0"/>
-          </a:p>
-        </p:txBody>
-      </p:sp>
-      <p:sp>
-        <p:nvSpPr>
-          <p:cNvPr id="3" name="Text 1"/>
-          <p:cNvSpPr/>
-          <p:nvPr/>
-        </p:nvSpPr>
-        <p:spPr>
-          <a:xfrm>
-            <a:off x="566928" y="548640"/>
-            <a:ext cx="11027664" cy="548640"/>
-          </a:xfrm>
-          <a:prstGeom prst="rect">
-            <a:avLst/>
-          </a:prstGeom>
-          <a:noFill/>
-          <a:ln/>
-        </p:spPr>
-        <p:txBody>
-          <a:bodyPr wrap="square" lIns="0" tIns="0" rIns="0" bIns="0" rtlCol="0" anchor="ctr"/>
-          <a:lstStyle/>
-          <a:p>
-            <a:pPr indent="0" marL="0">
-              <a:buNone/>
-            </a:pPr>
-            <a:r>
-              <a:rPr lang="en-US" sz="2700" b="1" dirty="0">
-                <a:solidFill>
-                  <a:srgbClr val="12212E"/>
-                </a:solidFill>
-                <a:latin typeface="Cambria" pitchFamily="34" charset="0"/>
-                <a:ea typeface="Cambria" pitchFamily="34" charset="-122"/>
-                <a:cs typeface="Cambria" pitchFamily="34" charset="-120"/>
-              </a:rPr>
-              <a:t>The measured endpoint is an antibody, not a T cell</a:t>
-            </a:r>
-            <a:endParaRPr lang="en-US" sz="2700" dirty="0"/>
-          </a:p>
-        </p:txBody>
-      </p:sp>
-      <p:pic>
-        <p:nvPicPr>
-          <p:cNvPr id="4" name="Image 0" descr="/home/user/ClaudeCode/hla_ligand_immunogenicity/figures/fig4_tb_coincidence.png">    </p:cNvPr>
-          <p:cNvPicPr>
-            <a:picLocks noChangeAspect="1"/>
-          </p:cNvPicPr>
-          <p:nvPr/>
-        </p:nvPicPr>
-        <p:blipFill>
-          <a:blip r:embed="rId1"/>
-          <a:stretch>
-            <a:fillRect/>
-          </a:stretch>
-        </p:blipFill>
-        <p:spPr>
-          <a:xfrm>
-            <a:off x="566928" y="1115568"/>
-            <a:ext cx="11027664" cy="2834640"/>
-          </a:xfrm>
-          <a:prstGeom prst="rect">
-            <a:avLst/>
-          </a:prstGeom>
-        </p:spPr>
-      </p:pic>
-      <p:sp>
-        <p:nvSpPr>
-          <p:cNvPr id="5" name="Text 2"/>
-          <p:cNvSpPr/>
-          <p:nvPr/>
-        </p:nvSpPr>
-        <p:spPr>
-          <a:xfrm>
-            <a:off x="566928" y="4069080"/>
-            <a:ext cx="11027664" cy="502920"/>
-          </a:xfrm>
-          <a:prstGeom prst="rect">
-            <a:avLst/>
-          </a:prstGeom>
-          <a:noFill/>
-          <a:ln/>
-        </p:spPr>
-        <p:txBody>
-          <a:bodyPr wrap="square" lIns="0" tIns="0" rIns="0" bIns="0" rtlCol="0" anchor="ctr"/>
-          <a:lstStyle/>
-          <a:p>
-            <a:pPr indent="0" marL="0">
-              <a:lnSpc>
-                <a:spcPts val="1600"/>
-              </a:lnSpc>
-              <a:buNone/>
-            </a:pPr>
-            <a:r>
-              <a:rPr lang="en-US" sz="1200" dirty="0">
-                <a:solidFill>
-                  <a:srgbClr val="12212E"/>
-                </a:solidFill>
-                <a:latin typeface="Calibri" pitchFamily="34" charset="0"/>
-                <a:ea typeface="Calibri" pitchFamily="34" charset="-122"/>
-                <a:cs typeface="Calibri" pitchFamily="34" charset="-120"/>
-              </a:rPr>
-              <a:t>A B cell only class-switches with help from a CD4 T cell recognising a peptide from the same protein. The regions worth taking into wet-lab work first are those where a non-self DR cluster and a predicted B-cell epitope coincide — shaded above.</a:t>
-            </a:r>
-            <a:endParaRPr lang="en-US" sz="1200" dirty="0"/>
-          </a:p>
-        </p:txBody>
-      </p:sp>
-      <p:graphicFrame>
-        <p:nvGraphicFramePr>
-          <p:cNvPr id="10" name="Table 0"/>
-          <p:cNvGraphicFramePr>
-            <a:graphicFrameLocks noGrp="1"/>
-          </p:cNvGraphicFramePr>
-          <p:nvPr>
-            <p:extLst>
-              <p:ext uri="{D42A27DB-BD31-4B8C-83A1-F6EECF244321}">
-                <p14:modId xmlns:p14="http://schemas.microsoft.com/office/powerpoint/2010/main" val="1579011935"/>
-              </p:ext>
-            </p:extLst>
-          </p:nvPr>
-        </p:nvGraphicFramePr>
-        <p:xfrm>
-          <a:off x="566928" y="4663440"/>
-          <a:ext cx="11027664" cy="914400"/>
-        </p:xfrm>
-        <a:graphic>
-          <a:graphicData uri="http://schemas.openxmlformats.org/drawingml/2006/table">
-            <a:tbl>
-              <a:tblPr/>
-              <a:tblGrid>
-                <a:gridCol w="1371600"/>
-                <a:gridCol w="1188720"/>
-                <a:gridCol w="1554480"/>
-                <a:gridCol w="1371600"/>
-                <a:gridCol w="1097280"/>
-                <a:gridCol w="4443984"/>
-              </a:tblGrid>
-              <a:tr h="292608">
-                <a:tc>
-                  <a:txBody>
-                    <a:bodyPr/>
-                    <a:lstStyle/>
-                    <a:p>
-                      <a:pPr indent="0" marL="0">
-                        <a:buNone/>
-                      </a:pPr>
-                      <a:r>
-                        <a:rPr lang="en-US" sz="850" b="1" spc="60" kern="0" dirty="0">
-                          <a:solidFill>
-                            <a:srgbClr val="63748A"/>
-                          </a:solidFill>
-                          <a:latin typeface="Calibri" pitchFamily="34" charset="0"/>
-                          <a:ea typeface="Calibri" pitchFamily="34" charset="-122"/>
-                          <a:cs typeface="Calibri" pitchFamily="34" charset="-120"/>
-                        </a:rPr>
-                        <a:t>T-cell cluster</a:t>
-                      </a:r>
-                      <a:endParaRPr lang="en-US" sz="850" dirty="0">
-                        <a:latin typeface="Calibri" charset="0"/>
-                        <a:ea typeface="Calibri" charset="0"/>
-                        <a:cs typeface="Calibri" charset="0"/>
-                      </a:endParaRPr>
-                    </a:p>
-                  </a:txBody>
-                  <a:tcPr marL="91440" marR="91440" marT="45720" marB="45720" anchor="ctr">
-                    <a:lnL w="6350" cap="flat" cmpd="sng" algn="ctr">
-                      <a:solidFill>
-                        <a:srgbClr val="DCE4EC"/>
-                      </a:solidFill>
-                      <a:prstDash val="solid"/>
-                      <a:round/>
-                      <a:headEnd type="none" w="med" len="med"/>
-                      <a:tailEnd type="none" w="med" len="med"/>
-                    </a:lnL>
-                    <a:lnR w="6350" cap="flat" cmpd="sng" algn="ctr">
-                      <a:solidFill>
-                        <a:srgbClr val="DCE4EC"/>
-                      </a:solidFill>
-                      <a:prstDash val="solid"/>
-                      <a:round/>
-                      <a:headEnd type="none" w="med" len="med"/>
-                      <a:tailEnd type="none" w="med" len="med"/>
-                    </a:lnR>
-                    <a:lnT w="6350" cap="flat" cmpd="sng" algn="ctr">
-                      <a:solidFill>
-                        <a:srgbClr val="DCE4EC"/>
-                      </a:solidFill>
-                      <a:prstDash val="solid"/>
-                      <a:round/>
-                      <a:headEnd type="none" w="med" len="med"/>
-                      <a:tailEnd type="none" w="med" len="med"/>
-                    </a:lnT>
-                    <a:lnB w="6350" cap="flat" cmpd="sng" algn="ctr">
-                      <a:solidFill>
-                        <a:srgbClr val="DCE4EC"/>
-                      </a:solidFill>
-                      <a:prstDash val="solid"/>
-                      <a:round/>
-                      <a:headEnd type="none" w="med" len="med"/>
-                      <a:tailEnd type="none" w="med" len="med"/>
-                    </a:lnB>
-                    <a:solidFill>
-                      <a:srgbClr val="F2F6F9"/>
-                    </a:solidFill>
-                  </a:tcPr>
-                </a:tc>
-                <a:tc>
-                  <a:txBody>
-                    <a:bodyPr/>
-                    <a:lstStyle/>
-                    <a:p>
-                      <a:pPr indent="0" marL="0">
-                        <a:buNone/>
-                      </a:pPr>
-                      <a:r>
-                        <a:rPr lang="en-US" sz="850" b="1" spc="60" kern="0" dirty="0">
-                          <a:solidFill>
-                            <a:srgbClr val="63748A"/>
-                          </a:solidFill>
-                          <a:latin typeface="Calibri" pitchFamily="34" charset="0"/>
-                          <a:ea typeface="Calibri" pitchFamily="34" charset="-122"/>
-                          <a:cs typeface="Calibri" pitchFamily="34" charset="-120"/>
-                        </a:rPr>
-                        <a:t>Core</a:t>
-                      </a:r>
-                      <a:endParaRPr lang="en-US" sz="850" dirty="0">
-                        <a:latin typeface="Calibri" charset="0"/>
-                        <a:ea typeface="Calibri" charset="0"/>
-                        <a:cs typeface="Calibri" charset="0"/>
-                      </a:endParaRPr>
-                    </a:p>
-                  </a:txBody>
-                  <a:tcPr marL="91440" marR="91440" marT="45720" marB="45720" anchor="ctr">
-                    <a:lnL w="6350" cap="flat" cmpd="sng" algn="ctr">
-                      <a:solidFill>
-                        <a:srgbClr val="DCE4EC"/>
-                      </a:solidFill>
-                      <a:prstDash val="solid"/>
-                      <a:round/>
-                      <a:headEnd type="none" w="med" len="med"/>
-                      <a:tailEnd type="none" w="med" len="med"/>
-                    </a:lnL>
-                    <a:lnR w="6350" cap="flat" cmpd="sng" algn="ctr">
-                      <a:solidFill>
-                        <a:srgbClr val="DCE4EC"/>
-                      </a:solidFill>
-                      <a:prstDash val="solid"/>
-                      <a:round/>
-                      <a:headEnd type="none" w="med" len="med"/>
-                      <a:tailEnd type="none" w="med" len="med"/>
-                    </a:lnR>
-                    <a:lnT w="6350" cap="flat" cmpd="sng" algn="ctr">
-                      <a:solidFill>
-                        <a:srgbClr val="DCE4EC"/>
-                      </a:solidFill>
-                      <a:prstDash val="solid"/>
-                      <a:round/>
-                      <a:headEnd type="none" w="med" len="med"/>
-                      <a:tailEnd type="none" w="med" len="med"/>
-                    </a:lnT>
-                    <a:lnB w="6350" cap="flat" cmpd="sng" algn="ctr">
-                      <a:solidFill>
-                        <a:srgbClr val="DCE4EC"/>
-                      </a:solidFill>
-                      <a:prstDash val="solid"/>
-                      <a:round/>
-                      <a:headEnd type="none" w="med" len="med"/>
-                      <a:tailEnd type="none" w="med" len="med"/>
-                    </a:lnB>
-                    <a:solidFill>
-                      <a:srgbClr val="F2F6F9"/>
-                    </a:solidFill>
-                  </a:tcPr>
-                </a:tc>
-                <a:tc>
-                  <a:txBody>
-                    <a:bodyPr/>
-                    <a:lstStyle/>
-                    <a:p>
-                      <a:pPr indent="0" marL="0">
-                        <a:buNone/>
-                      </a:pPr>
-                      <a:r>
-                        <a:rPr lang="en-US" sz="850" b="1" spc="60" kern="0" dirty="0">
-                          <a:solidFill>
-                            <a:srgbClr val="63748A"/>
-                          </a:solidFill>
-                          <a:latin typeface="Calibri" pitchFamily="34" charset="0"/>
-                          <a:ea typeface="Calibri" pitchFamily="34" charset="-122"/>
-                          <a:cs typeface="Calibri" pitchFamily="34" charset="-120"/>
-                        </a:rPr>
-                        <a:t>% pop presenting</a:t>
-                      </a:r>
-                      <a:endParaRPr lang="en-US" sz="850" dirty="0">
-                        <a:latin typeface="Calibri" charset="0"/>
-                        <a:ea typeface="Calibri" charset="0"/>
-                        <a:cs typeface="Calibri" charset="0"/>
-                      </a:endParaRPr>
-                    </a:p>
-                  </a:txBody>
-                  <a:tcPr marL="91440" marR="91440" marT="45720" marB="45720" anchor="ctr">
-                    <a:lnL w="6350" cap="flat" cmpd="sng" algn="ctr">
-                      <a:solidFill>
-                        <a:srgbClr val="DCE4EC"/>
-                      </a:solidFill>
-                      <a:prstDash val="solid"/>
-                      <a:round/>
-                      <a:headEnd type="none" w="med" len="med"/>
-                      <a:tailEnd type="none" w="med" len="med"/>
-                    </a:lnL>
-                    <a:lnR w="6350" cap="flat" cmpd="sng" algn="ctr">
-                      <a:solidFill>
-                        <a:srgbClr val="DCE4EC"/>
-                      </a:solidFill>
-                      <a:prstDash val="solid"/>
-                      <a:round/>
-                      <a:headEnd type="none" w="med" len="med"/>
-                      <a:tailEnd type="none" w="med" len="med"/>
-                    </a:lnR>
-                    <a:lnT w="6350" cap="flat" cmpd="sng" algn="ctr">
-                      <a:solidFill>
-                        <a:srgbClr val="DCE4EC"/>
-                      </a:solidFill>
-                      <a:prstDash val="solid"/>
-                      <a:round/>
-                      <a:headEnd type="none" w="med" len="med"/>
-                      <a:tailEnd type="none" w="med" len="med"/>
-                    </a:lnT>
-                    <a:lnB w="6350" cap="flat" cmpd="sng" algn="ctr">
-                      <a:solidFill>
-                        <a:srgbClr val="DCE4EC"/>
-                      </a:solidFill>
-                      <a:prstDash val="solid"/>
-                      <a:round/>
-                      <a:headEnd type="none" w="med" len="med"/>
-                      <a:tailEnd type="none" w="med" len="med"/>
-                    </a:lnB>
-                    <a:solidFill>
-                      <a:srgbClr val="F2F6F9"/>
-                    </a:solidFill>
-                  </a:tcPr>
-                </a:tc>
-                <a:tc>
-                  <a:txBody>
-                    <a:bodyPr/>
-                    <a:lstStyle/>
-                    <a:p>
-                      <a:pPr indent="0" marL="0">
-                        <a:buNone/>
-                      </a:pPr>
-                      <a:r>
-                        <a:rPr lang="en-US" sz="850" b="1" spc="60" kern="0" dirty="0">
-                          <a:solidFill>
-                            <a:srgbClr val="63748A"/>
-                          </a:solidFill>
-                          <a:latin typeface="Calibri" pitchFamily="34" charset="0"/>
-                          <a:ea typeface="Calibri" pitchFamily="34" charset="-122"/>
-                          <a:cs typeface="Calibri" pitchFamily="34" charset="-120"/>
-                        </a:rPr>
-                        <a:t>B-cell region</a:t>
-                      </a:r>
-                      <a:endParaRPr lang="en-US" sz="850" dirty="0">
-                        <a:latin typeface="Calibri" charset="0"/>
-                        <a:ea typeface="Calibri" charset="0"/>
-                        <a:cs typeface="Calibri" charset="0"/>
-                      </a:endParaRPr>
-                    </a:p>
-                  </a:txBody>
-                  <a:tcPr marL="91440" marR="91440" marT="45720" marB="45720" anchor="ctr">
-                    <a:lnL w="6350" cap="flat" cmpd="sng" algn="ctr">
-                      <a:solidFill>
-                        <a:srgbClr val="DCE4EC"/>
-                      </a:solidFill>
-                      <a:prstDash val="solid"/>
-                      <a:round/>
-                      <a:headEnd type="none" w="med" len="med"/>
-                      <a:tailEnd type="none" w="med" len="med"/>
-                    </a:lnL>
-                    <a:lnR w="6350" cap="flat" cmpd="sng" algn="ctr">
-                      <a:solidFill>
-                        <a:srgbClr val="DCE4EC"/>
-                      </a:solidFill>
-                      <a:prstDash val="solid"/>
-                      <a:round/>
-                      <a:headEnd type="none" w="med" len="med"/>
-                      <a:tailEnd type="none" w="med" len="med"/>
-                    </a:lnR>
-                    <a:lnT w="6350" cap="flat" cmpd="sng" algn="ctr">
-                      <a:solidFill>
-                        <a:srgbClr val="DCE4EC"/>
-                      </a:solidFill>
-                      <a:prstDash val="solid"/>
-                      <a:round/>
-                      <a:headEnd type="none" w="med" len="med"/>
-                      <a:tailEnd type="none" w="med" len="med"/>
-                    </a:lnT>
-                    <a:lnB w="6350" cap="flat" cmpd="sng" algn="ctr">
-                      <a:solidFill>
-                        <a:srgbClr val="DCE4EC"/>
-                      </a:solidFill>
-                      <a:prstDash val="solid"/>
-                      <a:round/>
-                      <a:headEnd type="none" w="med" len="med"/>
-                      <a:tailEnd type="none" w="med" len="med"/>
-                    </a:lnB>
-                    <a:solidFill>
-                      <a:srgbClr val="F2F6F9"/>
-                    </a:solidFill>
-                  </a:tcPr>
-                </a:tc>
-                <a:tc>
-                  <a:txBody>
-                    <a:bodyPr/>
-                    <a:lstStyle/>
-                    <a:p>
-                      <a:pPr indent="0" marL="0">
-                        <a:buNone/>
-                      </a:pPr>
-                      <a:r>
-                        <a:rPr lang="en-US" sz="850" b="1" spc="60" kern="0" dirty="0">
-                          <a:solidFill>
-                            <a:srgbClr val="63748A"/>
-                          </a:solidFill>
-                          <a:latin typeface="Calibri" pitchFamily="34" charset="0"/>
-                          <a:ea typeface="Calibri" pitchFamily="34" charset="-122"/>
-                          <a:cs typeface="Calibri" pitchFamily="34" charset="-120"/>
-                        </a:rPr>
-                        <a:t>Overlap (aa)</a:t>
-                      </a:r>
-                      <a:endParaRPr lang="en-US" sz="850" dirty="0">
-                        <a:latin typeface="Calibri" charset="0"/>
-                        <a:ea typeface="Calibri" charset="0"/>
-                        <a:cs typeface="Calibri" charset="0"/>
-                      </a:endParaRPr>
-                    </a:p>
-                  </a:txBody>
-                  <a:tcPr marL="91440" marR="91440" marT="45720" marB="45720" anchor="ctr">
-                    <a:lnL w="6350" cap="flat" cmpd="sng" algn="ctr">
-                      <a:solidFill>
-                        <a:srgbClr val="DCE4EC"/>
-                      </a:solidFill>
-                      <a:prstDash val="solid"/>
-                      <a:round/>
-                      <a:headEnd type="none" w="med" len="med"/>
-                      <a:tailEnd type="none" w="med" len="med"/>
-                    </a:lnL>
-                    <a:lnR w="6350" cap="flat" cmpd="sng" algn="ctr">
-                      <a:solidFill>
-                        <a:srgbClr val="DCE4EC"/>
-                      </a:solidFill>
-                      <a:prstDash val="solid"/>
-                      <a:round/>
-                      <a:headEnd type="none" w="med" len="med"/>
-                      <a:tailEnd type="none" w="med" len="med"/>
-                    </a:lnR>
-                    <a:lnT w="6350" cap="flat" cmpd="sng" algn="ctr">
-                      <a:solidFill>
-                        <a:srgbClr val="DCE4EC"/>
-                      </a:solidFill>
-                      <a:prstDash val="solid"/>
-                      <a:round/>
-                      <a:headEnd type="none" w="med" len="med"/>
-                      <a:tailEnd type="none" w="med" len="med"/>
-                    </a:lnT>
-                    <a:lnB w="6350" cap="flat" cmpd="sng" algn="ctr">
-                      <a:solidFill>
-                        <a:srgbClr val="DCE4EC"/>
-                      </a:solidFill>
-                      <a:prstDash val="solid"/>
-                      <a:round/>
-                      <a:headEnd type="none" w="med" len="med"/>
-                      <a:tailEnd type="none" w="med" len="med"/>
-                    </a:lnB>
-                    <a:solidFill>
-                      <a:srgbClr val="F2F6F9"/>
-                    </a:solidFill>
-                  </a:tcPr>
-                </a:tc>
-                <a:tc>
-                  <a:txBody>
-                    <a:bodyPr/>
-                    <a:lstStyle/>
-                    <a:p>
-                      <a:pPr indent="0" marL="0">
-                        <a:buNone/>
-                      </a:pPr>
-                      <a:r>
-                        <a:rPr lang="en-US" sz="850" b="1" spc="60" kern="0" dirty="0">
-                          <a:solidFill>
-                            <a:srgbClr val="63748A"/>
-                          </a:solidFill>
-                          <a:latin typeface="Calibri" pitchFamily="34" charset="0"/>
-                          <a:ea typeface="Calibri" pitchFamily="34" charset="-122"/>
-                          <a:cs typeface="Calibri" pitchFamily="34" charset="-120"/>
-                        </a:rPr>
-                        <a:t>Region sequence</a:t>
-                      </a:r>
-                      <a:endParaRPr lang="en-US" sz="850" dirty="0">
-                        <a:latin typeface="Calibri" charset="0"/>
-                        <a:ea typeface="Calibri" charset="0"/>
-                        <a:cs typeface="Calibri" charset="0"/>
-                      </a:endParaRPr>
-                    </a:p>
-                  </a:txBody>
-                  <a:tcPr marL="91440" marR="91440" marT="45720" marB="45720" anchor="ctr">
-                    <a:lnL w="6350" cap="flat" cmpd="sng" algn="ctr">
-                      <a:solidFill>
-                        <a:srgbClr val="DCE4EC"/>
-                      </a:solidFill>
-                      <a:prstDash val="solid"/>
-                      <a:round/>
-                      <a:headEnd type="none" w="med" len="med"/>
-                      <a:tailEnd type="none" w="med" len="med"/>
-                    </a:lnL>
-                    <a:lnR w="6350" cap="flat" cmpd="sng" algn="ctr">
-                      <a:solidFill>
-                        <a:srgbClr val="DCE4EC"/>
-                      </a:solidFill>
-                      <a:prstDash val="solid"/>
-                      <a:round/>
-                      <a:headEnd type="none" w="med" len="med"/>
-                      <a:tailEnd type="none" w="med" len="med"/>
-                    </a:lnR>
-                    <a:lnT w="6350" cap="flat" cmpd="sng" algn="ctr">
-                      <a:solidFill>
-                        <a:srgbClr val="DCE4EC"/>
-                      </a:solidFill>
-                      <a:prstDash val="solid"/>
-                      <a:round/>
-                      <a:headEnd type="none" w="med" len="med"/>
-                      <a:tailEnd type="none" w="med" len="med"/>
-                    </a:lnT>
-                    <a:lnB w="6350" cap="flat" cmpd="sng" algn="ctr">
-                      <a:solidFill>
-                        <a:srgbClr val="DCE4EC"/>
-                      </a:solidFill>
-                      <a:prstDash val="solid"/>
-                      <a:round/>
-                      <a:headEnd type="none" w="med" len="med"/>
-                      <a:tailEnd type="none" w="med" len="med"/>
-                    </a:lnB>
-                    <a:solidFill>
-                      <a:srgbClr val="F2F6F9"/>
-                    </a:solidFill>
-                  </a:tcPr>
-                </a:tc>
-              </a:tr>
-              <a:tr h="292608">
-                <a:tc>
-                  <a:txBody>
-                    <a:bodyPr/>
-                    <a:lstStyle/>
-                    <a:p>
-                      <a:pPr indent="0" marL="0">
-                        <a:buNone/>
-                      </a:pPr>
-                      <a:r>
-                        <a:rPr lang="en-US" sz="1000" dirty="0">
-                          <a:solidFill>
-                            <a:srgbClr val="12212E"/>
-                          </a:solidFill>
-                          <a:latin typeface="Calibri" pitchFamily="34" charset="0"/>
-                          <a:ea typeface="Calibri" pitchFamily="34" charset="-122"/>
-                          <a:cs typeface="Calibri" pitchFamily="34" charset="-120"/>
-                        </a:rPr>
-                        <a:t>47-56</a:t>
-                      </a:r>
-                      <a:endParaRPr lang="en-US" sz="1000" dirty="0">
-                        <a:latin typeface="Calibri" charset="0"/>
-                        <a:ea typeface="Calibri" charset="0"/>
-                        <a:cs typeface="Calibri" charset="0"/>
-                      </a:endParaRPr>
-                    </a:p>
-                  </a:txBody>
-                  <a:tcPr marL="91440" marR="91440" marT="45720" marB="45720" anchor="ctr">
-                    <a:lnL w="6350" cap="flat" cmpd="sng" algn="ctr">
-                      <a:solidFill>
-                        <a:srgbClr val="DCE4EC"/>
-                      </a:solidFill>
-                      <a:prstDash val="solid"/>
-                      <a:round/>
-                      <a:headEnd type="none" w="med" len="med"/>
-                      <a:tailEnd type="none" w="med" len="med"/>
-                    </a:lnL>
-                    <a:lnR w="6350" cap="flat" cmpd="sng" algn="ctr">
-                      <a:solidFill>
-                        <a:srgbClr val="DCE4EC"/>
-                      </a:solidFill>
-                      <a:prstDash val="solid"/>
-                      <a:round/>
-                      <a:headEnd type="none" w="med" len="med"/>
-                      <a:tailEnd type="none" w="med" len="med"/>
-                    </a:lnR>
-                    <a:lnT w="6350" cap="flat" cmpd="sng" algn="ctr">
-                      <a:solidFill>
-                        <a:srgbClr val="DCE4EC"/>
-                      </a:solidFill>
-                      <a:prstDash val="solid"/>
-                      <a:round/>
-                      <a:headEnd type="none" w="med" len="med"/>
-                      <a:tailEnd type="none" w="med" len="med"/>
-                    </a:lnT>
-                    <a:lnB w="6350" cap="flat" cmpd="sng" algn="ctr">
-                      <a:solidFill>
-                        <a:srgbClr val="DCE4EC"/>
-                      </a:solidFill>
-                      <a:prstDash val="solid"/>
-                      <a:round/>
-                      <a:headEnd type="none" w="med" len="med"/>
-                      <a:tailEnd type="none" w="med" len="med"/>
-                    </a:lnB>
-                  </a:tcPr>
-                </a:tc>
-                <a:tc>
-                  <a:txBody>
-                    <a:bodyPr/>
-                    <a:lstStyle/>
-                    <a:p>
-                      <a:pPr indent="0" marL="0">
-                        <a:buNone/>
-                      </a:pPr>
-                      <a:r>
-                        <a:rPr lang="en-US" sz="1000" b="1" dirty="0">
-                          <a:solidFill>
-                            <a:srgbClr val="12212E"/>
-                          </a:solidFill>
-                          <a:latin typeface="Courier New" pitchFamily="34" charset="0"/>
-                          <a:ea typeface="Courier New" pitchFamily="34" charset="-122"/>
-                          <a:cs typeface="Courier New" pitchFamily="34" charset="-120"/>
-                        </a:rPr>
-                        <a:t>FVAVQDITA</a:t>
-                      </a:r>
-                      <a:endParaRPr lang="en-US" sz="1000" dirty="0">
-                        <a:latin typeface="Courier New" charset="0"/>
-                        <a:ea typeface="Courier New" charset="0"/>
-                        <a:cs typeface="Courier New" charset="0"/>
-                      </a:endParaRPr>
-                    </a:p>
-                  </a:txBody>
-                  <a:tcPr marL="91440" marR="91440" marT="45720" marB="45720" anchor="ctr">
-                    <a:lnL w="6350" cap="flat" cmpd="sng" algn="ctr">
-                      <a:solidFill>
-                        <a:srgbClr val="DCE4EC"/>
-                      </a:solidFill>
-                      <a:prstDash val="solid"/>
-                      <a:round/>
-                      <a:headEnd type="none" w="med" len="med"/>
-                      <a:tailEnd type="none" w="med" len="med"/>
-                    </a:lnL>
-                    <a:lnR w="6350" cap="flat" cmpd="sng" algn="ctr">
-                      <a:solidFill>
-                        <a:srgbClr val="DCE4EC"/>
-                      </a:solidFill>
-                      <a:prstDash val="solid"/>
-                      <a:round/>
-                      <a:headEnd type="none" w="med" len="med"/>
-                      <a:tailEnd type="none" w="med" len="med"/>
-                    </a:lnR>
-                    <a:lnT w="6350" cap="flat" cmpd="sng" algn="ctr">
-                      <a:solidFill>
-                        <a:srgbClr val="DCE4EC"/>
-                      </a:solidFill>
-                      <a:prstDash val="solid"/>
-                      <a:round/>
-                      <a:headEnd type="none" w="med" len="med"/>
-                      <a:tailEnd type="none" w="med" len="med"/>
-                    </a:lnT>
-                    <a:lnB w="6350" cap="flat" cmpd="sng" algn="ctr">
-                      <a:solidFill>
-                        <a:srgbClr val="DCE4EC"/>
-                      </a:solidFill>
-                      <a:prstDash val="solid"/>
-                      <a:round/>
-                      <a:headEnd type="none" w="med" len="med"/>
-                      <a:tailEnd type="none" w="med" len="med"/>
-                    </a:lnB>
-                  </a:tcPr>
-                </a:tc>
-                <a:tc>
-                  <a:txBody>
-                    <a:bodyPr/>
-                    <a:lstStyle/>
-                    <a:p>
-                      <a:pPr algn="r" indent="0" marL="0">
-                        <a:buNone/>
-                      </a:pPr>
-                      <a:r>
-                        <a:rPr lang="en-US" sz="1000" b="1" dirty="0">
-                          <a:solidFill>
-                            <a:srgbClr val="12212E"/>
-                          </a:solidFill>
-                          <a:latin typeface="Calibri" pitchFamily="34" charset="0"/>
-                          <a:ea typeface="Calibri" pitchFamily="34" charset="-122"/>
-                          <a:cs typeface="Calibri" pitchFamily="34" charset="-120"/>
-                        </a:rPr>
-                        <a:t>28.5%</a:t>
-                      </a:r>
-                      <a:endParaRPr lang="en-US" sz="1000" dirty="0">
-                        <a:latin typeface="Calibri" charset="0"/>
-                        <a:ea typeface="Calibri" charset="0"/>
-                        <a:cs typeface="Calibri" charset="0"/>
-                      </a:endParaRPr>
-                    </a:p>
-                  </a:txBody>
-                  <a:tcPr marL="91440" marR="91440" marT="45720" marB="45720" anchor="ctr">
-                    <a:lnL w="6350" cap="flat" cmpd="sng" algn="ctr">
-                      <a:solidFill>
-                        <a:srgbClr val="DCE4EC"/>
-                      </a:solidFill>
-                      <a:prstDash val="solid"/>
-                      <a:round/>
-                      <a:headEnd type="none" w="med" len="med"/>
-                      <a:tailEnd type="none" w="med" len="med"/>
-                    </a:lnL>
-                    <a:lnR w="6350" cap="flat" cmpd="sng" algn="ctr">
-                      <a:solidFill>
-                        <a:srgbClr val="DCE4EC"/>
-                      </a:solidFill>
-                      <a:prstDash val="solid"/>
-                      <a:round/>
-                      <a:headEnd type="none" w="med" len="med"/>
-                      <a:tailEnd type="none" w="med" len="med"/>
-                    </a:lnR>
-                    <a:lnT w="6350" cap="flat" cmpd="sng" algn="ctr">
-                      <a:solidFill>
-                        <a:srgbClr val="DCE4EC"/>
-                      </a:solidFill>
-                      <a:prstDash val="solid"/>
-                      <a:round/>
-                      <a:headEnd type="none" w="med" len="med"/>
-                      <a:tailEnd type="none" w="med" len="med"/>
-                    </a:lnT>
-                    <a:lnB w="6350" cap="flat" cmpd="sng" algn="ctr">
-                      <a:solidFill>
-                        <a:srgbClr val="DCE4EC"/>
-                      </a:solidFill>
-                      <a:prstDash val="solid"/>
-                      <a:round/>
-                      <a:headEnd type="none" w="med" len="med"/>
-                      <a:tailEnd type="none" w="med" len="med"/>
-                    </a:lnB>
-                  </a:tcPr>
-                </a:tc>
-                <a:tc>
-                  <a:txBody>
-                    <a:bodyPr/>
-                    <a:lstStyle/>
-                    <a:p>
-                      <a:pPr indent="0" marL="0">
-                        <a:buNone/>
-                      </a:pPr>
-                      <a:r>
-                        <a:rPr lang="en-US" sz="1000" dirty="0">
-                          <a:solidFill>
-                            <a:srgbClr val="12212E"/>
-                          </a:solidFill>
-                          <a:latin typeface="Calibri" pitchFamily="34" charset="0"/>
-                          <a:ea typeface="Calibri" pitchFamily="34" charset="-122"/>
-                          <a:cs typeface="Calibri" pitchFamily="34" charset="-120"/>
-                        </a:rPr>
-                        <a:t>53-63</a:t>
-                      </a:r>
-                      <a:endParaRPr lang="en-US" sz="1000" dirty="0">
-                        <a:latin typeface="Calibri" charset="0"/>
-                        <a:ea typeface="Calibri" charset="0"/>
-                        <a:cs typeface="Calibri" charset="0"/>
-                      </a:endParaRPr>
-                    </a:p>
-                  </a:txBody>
-                  <a:tcPr marL="91440" marR="91440" marT="45720" marB="45720" anchor="ctr">
-                    <a:lnL w="6350" cap="flat" cmpd="sng" algn="ctr">
-                      <a:solidFill>
-                        <a:srgbClr val="DCE4EC"/>
-                      </a:solidFill>
-                      <a:prstDash val="solid"/>
-                      <a:round/>
-                      <a:headEnd type="none" w="med" len="med"/>
-                      <a:tailEnd type="none" w="med" len="med"/>
-                    </a:lnL>
-                    <a:lnR w="6350" cap="flat" cmpd="sng" algn="ctr">
-                      <a:solidFill>
-                        <a:srgbClr val="DCE4EC"/>
-                      </a:solidFill>
-                      <a:prstDash val="solid"/>
-                      <a:round/>
-                      <a:headEnd type="none" w="med" len="med"/>
-                      <a:tailEnd type="none" w="med" len="med"/>
-                    </a:lnR>
-                    <a:lnT w="6350" cap="flat" cmpd="sng" algn="ctr">
-                      <a:solidFill>
-                        <a:srgbClr val="DCE4EC"/>
-                      </a:solidFill>
-                      <a:prstDash val="solid"/>
-                      <a:round/>
-                      <a:headEnd type="none" w="med" len="med"/>
-                      <a:tailEnd type="none" w="med" len="med"/>
-                    </a:lnT>
-                    <a:lnB w="6350" cap="flat" cmpd="sng" algn="ctr">
-                      <a:solidFill>
-                        <a:srgbClr val="DCE4EC"/>
-                      </a:solidFill>
-                      <a:prstDash val="solid"/>
-                      <a:round/>
-                      <a:headEnd type="none" w="med" len="med"/>
-                      <a:tailEnd type="none" w="med" len="med"/>
-                    </a:lnB>
-                  </a:tcPr>
-                </a:tc>
-                <a:tc>
-                  <a:txBody>
-                    <a:bodyPr/>
-                    <a:lstStyle/>
-                    <a:p>
-                      <a:pPr algn="r" indent="0" marL="0">
-                        <a:buNone/>
-                      </a:pPr>
-                      <a:r>
-                        <a:rPr lang="en-US" sz="1000" dirty="0">
-                          <a:solidFill>
-                            <a:srgbClr val="12212E"/>
-                          </a:solidFill>
-                          <a:latin typeface="Calibri" pitchFamily="34" charset="0"/>
-                          <a:ea typeface="Calibri" pitchFamily="34" charset="-122"/>
-                          <a:cs typeface="Calibri" pitchFamily="34" charset="-120"/>
-                        </a:rPr>
-                        <a:t>4</a:t>
-                      </a:r>
-                      <a:endParaRPr lang="en-US" sz="1000" dirty="0">
-                        <a:latin typeface="Calibri" charset="0"/>
-                        <a:ea typeface="Calibri" charset="0"/>
-                        <a:cs typeface="Calibri" charset="0"/>
-                      </a:endParaRPr>
-                    </a:p>
-                  </a:txBody>
-                  <a:tcPr marL="91440" marR="91440" marT="45720" marB="45720" anchor="ctr">
-                    <a:lnL w="6350" cap="flat" cmpd="sng" algn="ctr">
-                      <a:solidFill>
-                        <a:srgbClr val="DCE4EC"/>
-                      </a:solidFill>
-                      <a:prstDash val="solid"/>
-                      <a:round/>
-                      <a:headEnd type="none" w="med" len="med"/>
-                      <a:tailEnd type="none" w="med" len="med"/>
-                    </a:lnL>
-                    <a:lnR w="6350" cap="flat" cmpd="sng" algn="ctr">
-                      <a:solidFill>
-                        <a:srgbClr val="DCE4EC"/>
-                      </a:solidFill>
-                      <a:prstDash val="solid"/>
-                      <a:round/>
-                      <a:headEnd type="none" w="med" len="med"/>
-                      <a:tailEnd type="none" w="med" len="med"/>
-                    </a:lnR>
-                    <a:lnT w="6350" cap="flat" cmpd="sng" algn="ctr">
-                      <a:solidFill>
-                        <a:srgbClr val="DCE4EC"/>
-                      </a:solidFill>
-                      <a:prstDash val="solid"/>
-                      <a:round/>
-                      <a:headEnd type="none" w="med" len="med"/>
-                      <a:tailEnd type="none" w="med" len="med"/>
-                    </a:lnT>
-                    <a:lnB w="6350" cap="flat" cmpd="sng" algn="ctr">
-                      <a:solidFill>
-                        <a:srgbClr val="DCE4EC"/>
-                      </a:solidFill>
-                      <a:prstDash val="solid"/>
-                      <a:round/>
-                      <a:headEnd type="none" w="med" len="med"/>
-                      <a:tailEnd type="none" w="med" len="med"/>
-                    </a:lnB>
-                  </a:tcPr>
-                </a:tc>
-                <a:tc>
-                  <a:txBody>
-                    <a:bodyPr/>
-                    <a:lstStyle/>
-                    <a:p>
-                      <a:pPr indent="0" marL="0">
-                        <a:buNone/>
-                      </a:pPr>
-                      <a:r>
-                        <a:rPr lang="en-US" sz="850" dirty="0">
-                          <a:solidFill>
-                            <a:srgbClr val="12212E"/>
-                          </a:solidFill>
-                          <a:latin typeface="Courier New" pitchFamily="34" charset="0"/>
-                          <a:ea typeface="Courier New" pitchFamily="34" charset="-122"/>
-                          <a:cs typeface="Courier New" pitchFamily="34" charset="-120"/>
-                        </a:rPr>
-                        <a:t>ITASNTHYSSA</a:t>
-                      </a:r>
-                      <a:endParaRPr lang="en-US" sz="850" dirty="0">
-                        <a:latin typeface="Courier New" charset="0"/>
-                        <a:ea typeface="Courier New" charset="0"/>
-                        <a:cs typeface="Courier New" charset="0"/>
-                      </a:endParaRPr>
-                    </a:p>
-                  </a:txBody>
-                  <a:tcPr marL="91440" marR="91440" marT="45720" marB="45720" anchor="ctr">
-                    <a:lnL w="6350" cap="flat" cmpd="sng" algn="ctr">
-                      <a:solidFill>
-                        <a:srgbClr val="DCE4EC"/>
-                      </a:solidFill>
-                      <a:prstDash val="solid"/>
-                      <a:round/>
-                      <a:headEnd type="none" w="med" len="med"/>
-                      <a:tailEnd type="none" w="med" len="med"/>
-                    </a:lnL>
-                    <a:lnR w="6350" cap="flat" cmpd="sng" algn="ctr">
-                      <a:solidFill>
-                        <a:srgbClr val="DCE4EC"/>
-                      </a:solidFill>
-                      <a:prstDash val="solid"/>
-                      <a:round/>
-                      <a:headEnd type="none" w="med" len="med"/>
-                      <a:tailEnd type="none" w="med" len="med"/>
-                    </a:lnR>
-                    <a:lnT w="6350" cap="flat" cmpd="sng" algn="ctr">
-                      <a:solidFill>
-                        <a:srgbClr val="DCE4EC"/>
-                      </a:solidFill>
-                      <a:prstDash val="solid"/>
-                      <a:round/>
-                      <a:headEnd type="none" w="med" len="med"/>
-                      <a:tailEnd type="none" w="med" len="med"/>
-                    </a:lnT>
-                    <a:lnB w="6350" cap="flat" cmpd="sng" algn="ctr">
-                      <a:solidFill>
-                        <a:srgbClr val="DCE4EC"/>
-                      </a:solidFill>
-                      <a:prstDash val="solid"/>
-                      <a:round/>
-                      <a:headEnd type="none" w="med" len="med"/>
-                      <a:tailEnd type="none" w="med" len="med"/>
-                    </a:lnB>
-                  </a:tcPr>
-                </a:tc>
-              </a:tr>
-            </a:tbl>
-          </a:graphicData>
-        </a:graphic>
-      </p:graphicFrame>
-      <p:sp>
-        <p:nvSpPr>
-          <p:cNvPr id="7" name="Text 3"/>
-          <p:cNvSpPr/>
-          <p:nvPr/>
-        </p:nvSpPr>
-        <p:spPr>
-          <a:xfrm>
-            <a:off x="566928" y="6172200"/>
-            <a:ext cx="11027664" cy="502920"/>
-          </a:xfrm>
-          <a:prstGeom prst="rect">
-            <a:avLst/>
-          </a:prstGeom>
-          <a:noFill/>
-          <a:ln/>
-        </p:spPr>
-        <p:txBody>
-          <a:bodyPr wrap="square" lIns="0" tIns="0" rIns="0" bIns="0" rtlCol="0" anchor="ctr"/>
-          <a:lstStyle/>
-          <a:p>
-            <a:pPr indent="0" marL="0">
-              <a:lnSpc>
-                <a:spcPts val="1200"/>
-              </a:lnSpc>
-              <a:buNone/>
-            </a:pPr>
-            <a:r>
-              <a:rPr lang="en-US" sz="950" i="1" dirty="0">
-                <a:solidFill>
-                  <a:srgbClr val="63748A"/>
-                </a:solidFill>
-                <a:latin typeface="Calibri" pitchFamily="34" charset="0"/>
-                <a:ea typeface="Calibri" pitchFamily="34" charset="-122"/>
-                <a:cs typeface="Calibri" pitchFamily="34" charset="-120"/>
-              </a:rPr>
-              <a:t>BepiPred-2.0 linear B-cell propensity is the weakest model in this pipeline — most real ADA epitopes are conformational. This layer prioritises regions; it is never a standalone claim.</a:t>
-            </a:r>
-            <a:endParaRPr lang="en-US" sz="950" dirty="0"/>
-          </a:p>
-        </p:txBody>
-      </p:sp>
     </p:spTree>
   </p:cSld>
   <p:clrMapOvr>

</xml_diff>